<commit_message>
polishing synchronization part 1
</commit_message>
<xml_diff>
--- a/synchronization_part_1/synchronization_part_1.pptx
+++ b/synchronization_part_1/synchronization_part_1.pptx
@@ -6,7 +6,7 @@
     <p:sldMasterId id="2147483667" r:id="rId2"/>
   </p:sldMasterIdLst>
   <p:notesMasterIdLst>
-    <p:notesMasterId r:id="rId52"/>
+    <p:notesMasterId r:id="rId50"/>
   </p:notesMasterIdLst>
   <p:sldIdLst>
     <p:sldId id="330" r:id="rId3"/>
@@ -50,14 +50,12 @@
     <p:sldId id="340" r:id="rId41"/>
     <p:sldId id="280" r:id="rId42"/>
     <p:sldId id="283" r:id="rId43"/>
-    <p:sldId id="282" r:id="rId44"/>
-    <p:sldId id="284" r:id="rId45"/>
-    <p:sldId id="533" r:id="rId46"/>
-    <p:sldId id="527" r:id="rId47"/>
-    <p:sldId id="528" r:id="rId48"/>
-    <p:sldId id="529" r:id="rId49"/>
-    <p:sldId id="534" r:id="rId50"/>
-    <p:sldId id="535" r:id="rId51"/>
+    <p:sldId id="284" r:id="rId44"/>
+    <p:sldId id="533" r:id="rId45"/>
+    <p:sldId id="527" r:id="rId46"/>
+    <p:sldId id="529" r:id="rId47"/>
+    <p:sldId id="534" r:id="rId48"/>
+    <p:sldId id="535" r:id="rId49"/>
   </p:sldIdLst>
   <p:sldSz cx="12192000" cy="6858000"/>
   <p:notesSz cx="6858000" cy="9144000"/>
@@ -562,7 +560,7 @@
           <a:p>
             <a:fld id="{B9670FC7-431C-3445-825C-360F18AD9FB0}" type="datetimeFigureOut">
               <a:rPr lang="en-US" smtClean="0"/>
-              <a:t>7/15/26</a:t>
+              <a:t>9/15/26</a:t>
             </a:fld>
             <a:endParaRPr lang="en-US"/>
           </a:p>
@@ -1352,19 +1350,7 @@
               <a:rPr lang="en-US" sz="1300" dirty="0">
                 <a:latin typeface="Comic Sans MS" pitchFamily="66" charset="0"/>
               </a:rPr>
-              <a:t>This is called </a:t>
-            </a:r>
-            <a:r>
-              <a:rPr lang="en-US" sz="1300" dirty="0" err="1">
-                <a:latin typeface="Comic Sans MS" pitchFamily="66" charset="0"/>
-              </a:rPr>
-              <a:t>busywait</a:t>
-            </a:r>
-            <a:r>
-              <a:rPr lang="en-US" sz="1300" dirty="0">
-                <a:latin typeface="Comic Sans MS" pitchFamily="66" charset="0"/>
-              </a:rPr>
-              <a:t> because A is using CPU cycles to spin in a loop.</a:t>
+              <a:t>This is called busy-wait because A is using CPU cycles to spin in a loop.</a:t>
             </a:r>
           </a:p>
           <a:p>
@@ -1397,7 +1383,7 @@
               <a:rPr lang="en-US" sz="1300" dirty="0">
                 <a:latin typeface="Comic Sans MS" pitchFamily="66" charset="0"/>
               </a:rPr>
-              <a:t>Is this solution to the critical section problem valid or not?</a:t>
+              <a:t>Is this a solution to the critical-section problem valid or not?</a:t>
             </a:r>
           </a:p>
           <a:p>
@@ -1558,15 +1544,7 @@
             </a:r>
             <a:r>
               <a:rPr lang="en-US" noProof="0" dirty="0"/>
-              <a:t> is false to exit the </a:t>
-            </a:r>
-            <a:r>
-              <a:rPr lang="en-US" noProof="0" dirty="0" err="1"/>
-              <a:t>busywait</a:t>
-            </a:r>
-            <a:r>
-              <a:rPr lang="en-US" noProof="0" dirty="0"/>
-              <a:t> while loop (again, that's what the code says).</a:t>
+              <a:t> is false to exit the busy-wait while loop (again, that's what the code says).</a:t>
             </a:r>
           </a:p>
           <a:p>
@@ -1633,13 +1611,8 @@
             </a:r>
             <a:r>
               <a:rPr lang="en-US" noProof="0" dirty="0"/>
-              <a:t>” for A is that if you place it there, then there can be another B in CS before the blue point and we are back to the same initial situation, so it’s about placing it after </a:t>
-            </a:r>
-            <a:r>
-              <a:rPr lang="en-US" noProof="0"/>
-              <a:t>the first blue dot</a:t>
-            </a:r>
-            <a:endParaRPr lang="en-US" noProof="0" dirty="0"/>
+              <a:t>” for A is that if you place it there, then there can be another B in CS before the blue point and we are back to the same initial situation, so it’s about placing it after the first blue dot</a:t>
+            </a:r>
           </a:p>
         </p:txBody>
       </p:sp>
@@ -1734,7 +1707,7 @@
           <a:p>
             <a:r>
               <a:rPr lang="en-US" noProof="0" dirty="0"/>
-              <a:t>In the example we are studying, the point in which B sets </a:t>
+              <a:t>In the example we are studying, the point at which B sets </a:t>
             </a:r>
             <a:r>
               <a:rPr lang="en-US" noProof="0" dirty="0" err="1"/>
@@ -1814,7 +1787,7 @@
           <a:p>
             <a:r>
               <a:rPr lang="en-US" noProof="0" dirty="0"/>
-              <a:t>We have found an example that breaks the mutual exclusion, which implies the code is NOT a solution to the critical section problem.</a:t>
+              <a:t>We have found an example that breaks the mutual exclusion, which implies the code is NOT a solution to the critical-section problem.</a:t>
             </a:r>
           </a:p>
         </p:txBody>
@@ -1910,7 +1883,7 @@
           <a:p>
             <a:r>
               <a:rPr lang="en-US" noProof="0" dirty="0"/>
-              <a:t>Once you listen to this argumentation, you "digest" it and you understand it, you will probably agree that proving whether a solution to the critical problem is valid or not is very challenging. In all the following videos, I strongly suggest you stop and try to formally find out yourself whether a solution is correct or not!</a:t>
+              <a:t>Once you listen to this argumentation, you "digest" it and you understand it, you will probably agree that proving whether a solution to the critical-section problem is valid or not is very challenging. In all the following videos, I strongly suggest you stop and try to formally find out yourself whether a solution is correct or not!</a:t>
             </a:r>
           </a:p>
         </p:txBody>
@@ -2102,15 +2075,7 @@
           <a:p>
             <a:r>
               <a:rPr lang="en-US" dirty="0"/>
-              <a:t>The entry section of each thread does a </a:t>
-            </a:r>
-            <a:r>
-              <a:rPr lang="en-US" dirty="0" err="1"/>
-              <a:t>busywait</a:t>
-            </a:r>
-            <a:r>
-              <a:rPr lang="en-US" dirty="0"/>
-              <a:t> loop until it does not see its id in the variable turn.</a:t>
+              <a:t>The entry section of each thread does a busy-wait loop while it does not see its id in the variable turn.</a:t>
             </a:r>
           </a:p>
           <a:p>
@@ -2122,7 +2087,7 @@
           <a:p>
             <a:r>
               <a:rPr lang="en-US" dirty="0"/>
-              <a:t>Is this a valid solution to the critical section problem?</a:t>
+              <a:t>Is this a valid solution to the critical-section problem?</a:t>
             </a:r>
             <a:endParaRPr lang="sv-SE" dirty="0"/>
           </a:p>
@@ -2465,7 +2430,7 @@
           <a:p>
             <a:r>
               <a:rPr lang="en-US" noProof="0" dirty="0"/>
-              <a:t>Can it happen that B does not put turn value to A in a bounded time? Yes, B can be in its remainder section and, as we said, the duration of the reminder section is arbitrarily long, which means the progress property is violated.</a:t>
+              <a:t>Can it happen that B does not put turn value to A in a bounded time? Yes, B can be in its remainder section and, as we said, the duration of the remainder section is arbitrarily long, which means the progress property is violated.</a:t>
             </a:r>
           </a:p>
         </p:txBody>
@@ -2561,7 +2526,7 @@
           <a:p>
             <a:r>
               <a:rPr lang="en-US" dirty="0"/>
-              <a:t>Can connect back to scheduling of OS threads. Need to have them run concurrently and in parallel, and coarse grained is not really enough. We want to minimize the exclusive access to only the actual required part, how do we do it?</a:t>
+              <a:t>Can connect back to scheduling of OS threads. Need to have them run concurrently and in parallel, and coarse-grained is not enough. We want to minimize the exclusive access to only the actual required part, how do we do it?</a:t>
             </a:r>
           </a:p>
           <a:p>
@@ -2654,15 +2619,7 @@
           <a:p>
             <a:r>
               <a:rPr lang="en-US" noProof="0" dirty="0"/>
-              <a:t>We can then conclude this code is not a valid solution to the </a:t>
-            </a:r>
-            <a:r>
-              <a:rPr lang="en-US" noProof="0"/>
-              <a:t>critical section problem</a:t>
-            </a:r>
-            <a:r>
-              <a:rPr lang="en-US" noProof="0" dirty="0"/>
-              <a:t>, because it breaks the progress property.</a:t>
+              <a:t>We can then conclude this code is not a valid solution to the critical-section problem, because it breaks the progress property.</a:t>
             </a:r>
           </a:p>
         </p:txBody>
@@ -2857,7 +2814,7 @@
           <a:p>
             <a:r>
               <a:rPr lang="en-US" dirty="0"/>
-              <a:t>In the entry section, thread A sets its flag to true, sets turn to B, and then waits until turn value is B and B's flag is true.</a:t>
+              <a:t>In the entry section, thread A sets its flag to true, sets turn to B, and then waits while turn value is B and B's flag is true.</a:t>
             </a:r>
           </a:p>
           <a:p>
@@ -3202,7 +3159,7 @@
           <a:p>
             <a:r>
               <a:rPr lang="en-US" noProof="0" dirty="0"/>
-              <a:t>[c] Notice in this case the value of turn was set to B by A in the second instruction of the entry section, but then B must have set it to A for A to read its id during the execution of the third instruction of the entry set.</a:t>
+              <a:t>[c] Notice in this case the value of turn was set to B by A in the second instruction of the entry section, but then B must have set it to A for A to read its id during the execution of the third instruction of the entry section.</a:t>
             </a:r>
           </a:p>
           <a:p>
@@ -3216,7 +3173,7 @@
             </a:r>
             <a:r>
               <a:rPr lang="en-US" noProof="0" dirty="0"/>
-              <a:t> B enters its while loop. Can it exit it and enter its critical section before A? No, because turn is set to </a:t>
+              <a:t>, B enters its while loop. Can it exit it and enter its critical section before A? No, because turn is set to </a:t>
             </a:r>
             <a:r>
               <a:rPr lang="en-US" noProof="0" dirty="0" err="1"/>
@@ -3232,7 +3189,7 @@
             </a:r>
             <a:r>
               <a:rPr lang="en-US" noProof="0" dirty="0"/>
-              <a:t> will remain true until A exits its critical section. So, also in this case, we cannot find a counter-example.</a:t>
+              <a:t> will remain true until A exits its critical section. So, also in this case, we cannot find a counterexample.</a:t>
             </a:r>
           </a:p>
           <a:p>
@@ -3328,7 +3285,7 @@
           <a:p>
             <a:r>
               <a:rPr lang="en-US" noProof="0" dirty="0"/>
-              <a:t>Now that we know mutual execution is guaranteed, let's check progress.</a:t>
+              <a:t>Now that we know mutual exclusion is guaranteed, let's check progress.</a:t>
             </a:r>
           </a:p>
           <a:p>
@@ -3362,7 +3319,7 @@
             </a:r>
             <a:r>
               <a:rPr lang="en-US" noProof="0" dirty="0"/>
-              <a:t>. But if B is in its reminder section, then </a:t>
+              <a:t>. But if B is in its remainder section, then </a:t>
             </a:r>
             <a:r>
               <a:rPr lang="en-US" noProof="0" dirty="0" err="1"/>
@@ -3400,7 +3357,7 @@
             </a:r>
             <a:r>
               <a:rPr lang="en-US" noProof="0" dirty="0"/>
-              <a:t> to false before entering its reminder section</a:t>
+              <a:t> to false before entering its remainder section</a:t>
             </a:r>
           </a:p>
         </p:txBody>
@@ -3511,8 +3468,13 @@
           <a:p>
             <a:r>
               <a:rPr lang="en-US" noProof="0" dirty="0"/>
-              <a:t>[c] What we are trying to find is an execution in which A enters again its critical section while B still waits. If this can happen once, then it can happen an unbounded number of times.</a:t>
-            </a:r>
+              <a:t>[c] What we are trying to find is an execution in which A enters again its critical section while B still waits. If this can happen once, then fairness </a:t>
+            </a:r>
+            <a:r>
+              <a:rPr lang="en-US" noProof="0"/>
+              <a:t>is compromised.</a:t>
+            </a:r>
+            <a:endParaRPr lang="en-US" noProof="0" dirty="0"/>
           </a:p>
           <a:p>
             <a:r>
@@ -3531,7 +3493,7 @@
           <a:p>
             <a:r>
               <a:rPr lang="en-US" noProof="0" dirty="0"/>
-              <a:t>[c] A runs its reminder section and then starts the loop again by setting </a:t>
+              <a:t>[c] A runs its remainder section and then starts the loop again by setting </a:t>
             </a:r>
             <a:r>
               <a:rPr lang="en-US" noProof="0" dirty="0" err="1"/>
@@ -3851,7 +3813,7 @@
           <a:p>
             <a:r>
               <a:rPr lang="en-US" dirty="0"/>
-              <a:t>Now that we have seen a valid solution to the critical section problem, let's look into how hardware can help us in this context.</a:t>
+              <a:t>Now that we have seen a valid solution to the critical-section problem, let's look into how hardware can help us in this context.</a:t>
             </a:r>
           </a:p>
           <a:p>
@@ -3878,7 +3840,7 @@
           <a:p>
             <a:r>
               <a:rPr lang="en-US" dirty="0"/>
-              <a:t>More importantly, the problem with this solution is that by disabling the interrupts on one core, threads running on different cores are still able to lead to behavior that does not satisfy the critical section problem.</a:t>
+              <a:t>More importantly, the problem with this solution is that by disabling the interrupts on one core, threads running on different cores are still able to lead to behavior that does not satisfy the critical-section problem.</a:t>
             </a:r>
           </a:p>
         </p:txBody>
@@ -4113,7 +4075,29 @@
             </a:r>
             <a:r>
               <a:rPr lang="en-US" dirty="0"/>
-              <a:t> variable, sets it to true and returns the previous value. As I said, this instruction is executed atomically, so it either runs in its entirety or it does not. Under the hood, the hardware is either disabling interrupts if the system is uniprocessor or locking the system bus if the system is a multiprocessor one.</a:t>
+              <a:t> variable, sets it to true and returns the previous value. As I said, this instruction is executed atomically, so it either runs in its entirety or it does not. Under the hood, it works because </a:t>
+            </a:r>
+            <a:r>
+              <a:rPr lang="en-US" sz="1200" kern="1200" dirty="0">
+                <a:solidFill>
+                  <a:schemeClr val="tx1"/>
+                </a:solidFill>
+                <a:effectLst/>
+                <a:latin typeface="+mn-lt"/>
+                <a:ea typeface="+mn-ea"/>
+                <a:cs typeface="+mn-cs"/>
+              </a:rPr>
+              <a:t>processors usually obtain exclusive ownership of the relevant cache line through the cache-coherence mechanism</a:t>
+            </a:r>
+            <a:r>
+              <a:rPr lang="en-US" dirty="0">
+                <a:effectLst/>
+              </a:rPr>
+              <a:t> </a:t>
+            </a:r>
+            <a:r>
+              <a:rPr lang="en-US" dirty="0"/>
+              <a:t>.</a:t>
             </a:r>
           </a:p>
           <a:p>
@@ -4639,7 +4623,7 @@
           <a:p>
             <a:r>
               <a:rPr lang="en-US" dirty="0"/>
-              <a:t>Something worth noticing about these solutions is that they are busy waiting / spinning. </a:t>
+              <a:t>Something worth noticing about these solutions is that they are busy-waiting / spinning. </a:t>
             </a:r>
           </a:p>
           <a:p>
@@ -4657,7 +4641,7 @@
           <a:p>
             <a:r>
               <a:rPr lang="en-US" dirty="0"/>
-              <a:t>[c] If you have tried to argue yourself about whether these are valid solutions to the critical section problem, you probably have reached the conclusion that from the fairness perspective, they are also not optimal.</a:t>
+              <a:t>[c] If you have tried to argue yourself about whether these are valid solutions to the critical-section problem, you probably have reached the conclusion that from the fairness perspective, they are also not optimal.</a:t>
             </a:r>
           </a:p>
           <a:p>
@@ -4672,15 +4656,7 @@
           <a:p>
             <a:r>
               <a:rPr lang="en-US" dirty="0"/>
-              <a:t>[c] The third point to think about is the underlying OS scheduling mechanism. Even if in this lecture we have not really made any assumption on the scheduling mechanism the underlying OS is using, you should not think we do not need to make assumptions when looking at a specific solution. For instance, if we assume the OS is running a non-preemptive priority-based scheduler and the thread that is spinning in its entry section is the one with the highest priority, then the solution can lead to a deadlock and no thread is actually able to make any </a:t>
-            </a:r>
-            <a:r>
-              <a:rPr lang="en-US" dirty="0" err="1"/>
-              <a:t>progess</a:t>
-            </a:r>
-            <a:r>
-              <a:rPr lang="en-US" dirty="0"/>
-              <a:t>.</a:t>
+              <a:t>[c] The third point to think about is the underlying OS scheduling mechanism. Even if in this lecture we have not really made any assumption on the scheduling mechanism the underlying OS is using, you should not think we do not need to make assumptions when looking at a specific solution. For instance, if we assume the OS is running a preemptive priority-based scheduler and the thread that is spinning in its entry section is the one with the highest priority, then the solution can lead to a deadlock, and no thread is able to make any progress.</a:t>
             </a:r>
           </a:p>
           <a:p>
@@ -4825,21 +4801,13 @@
           <a:p>
             <a:r>
               <a:rPr lang="en-US" dirty="0"/>
-              <a:t>The thread circles over the waiting array, starting from the next thread in the array (as if the buffer is circular) and then stops as soon as it finds one entry for which waiting is true or if completes the circle.</a:t>
+              <a:t>The thread circles over the waiting array, starting from the next thread in the array (as if the buffer is circular) and then stops as soon as it finds one entry for which waiting is true or if it completes the circle.</a:t>
             </a:r>
           </a:p>
           <a:p>
             <a:r>
               <a:rPr lang="en-US" dirty="0"/>
-              <a:t>If no other thread is waiting in its loop inside its entry section, then this thread sets lock to false, so some other thread that wants to enter its critical section later on can do so. Notice that the thread that enters its critical section next could be the thread that just set lock to false, but this cannot happen for an unbounded number of times (if another thread </a:t>
-            </a:r>
-            <a:r>
-              <a:rPr lang="en-US"/>
-              <a:t>is waiting), </a:t>
-            </a:r>
-            <a:r>
-              <a:rPr lang="en-US" dirty="0"/>
-              <a:t>since if another thread also wants to enter the critical section, then its entry in waiting will be true and the thread that manages to enter its critical section will then hand over the lock in its exit section, as shown in line 14.</a:t>
+              <a:t>If no other thread is waiting in its loop inside its entry section, then this thread sets lock to false, so some other thread that wants to enter its critical section later on can do so. Notice that the thread that enters its critical section next could be the thread that just set lock to false, but this cannot happen for an unbounded number of times (if another thread is waiting), since if another thread also wants to enter the critical section, then its entry in waiting will be true and the thread that manages to enter its critical section will then hand over the lock in its exit section, as shown in line 14.</a:t>
             </a:r>
           </a:p>
           <a:p>
@@ -5060,7 +5028,7 @@
           <a:p>
             <a:r>
               <a:rPr lang="en-US" dirty="0"/>
-              <a:t>When invoking wait on S, the thread invoking the function will loop or remain blocked until S value is 0. After that, it will exit after decreasing the value of S.</a:t>
+              <a:t>When invoking wait on S, the thread invoking the function will loop or wait while S is zero and proceed when S &gt; 0. After that, it will exit after decreasing the value of S.</a:t>
             </a:r>
           </a:p>
           <a:p>
@@ -5153,7 +5121,7 @@
           <a:p>
             <a:r>
               <a:rPr lang="en-US" dirty="0"/>
-              <a:t>At this point, you can hopefully see semaphores can be used as shown in this pseudocode to handle the critical section problem (but please try to reason formally by yourself!)</a:t>
+              <a:t>At this point, you can hopefully see semaphores can be used as shown in this pseudocode to handle the critical-section problem (but please try to reason formally by yourself!)</a:t>
             </a:r>
           </a:p>
         </p:txBody>
@@ -5256,7 +5224,7 @@
             </a:r>
             <a:r>
               <a:rPr lang="en-US" dirty="0"/>
-              <a:t> has been executed in Ta, we can do it as shown in the slide. Since B waits for a signal from A, and A sends a signal after </a:t>
+              <a:t> has been executed in TA, we can do it as shown in the slide. Since B waits for a signal from A, and A sends a signal after </a:t>
             </a:r>
             <a:r>
               <a:rPr lang="en-US" dirty="0" err="1"/>
@@ -5668,7 +5636,7 @@
           <a:p>
             <a:r>
               <a:rPr lang="en-US" dirty="0"/>
-              <a:t>In our previous lecture about multithreaded processes, we saw that functions like </a:t>
+              <a:t>In one of our previous lectures, the one about multithreaded processes, we saw that functions like </a:t>
             </a:r>
             <a:r>
               <a:rPr lang="en-US" dirty="0" err="1"/>
@@ -5927,7 +5895,7 @@
       </p:grpSpPr>
       <p:sp>
         <p:nvSpPr>
-          <p:cNvPr id="54274" name="Rectangle 7"/>
+          <p:cNvPr id="56322" name="Rectangle 7"/>
           <p:cNvSpPr>
             <a:spLocks noGrp="1" noChangeArrowheads="1"/>
           </p:cNvSpPr>
@@ -5959,7 +5927,7 @@
               <a:tabLst/>
               <a:defRPr/>
             </a:pPr>
-            <a:fld id="{B34677B0-FD6B-4B18-AFB8-01DF365B7CC8}" type="slidenum">
+            <a:fld id="{4DB15479-77C4-4247-86C7-895882BE5E1E}" type="slidenum">
               <a:rPr kumimoji="0" lang="en-US" sz="1200" b="0" i="0" u="none" strike="noStrike" kern="1200" cap="none" spc="0" normalizeH="0" baseline="0" noProof="0" smtClean="0">
                 <a:ln>
                   <a:noFill/>
@@ -6012,400 +5980,6 @@
       </p:sp>
       <p:sp>
         <p:nvSpPr>
-          <p:cNvPr id="54275" name="Rectangle 2"/>
-          <p:cNvSpPr>
-            <a:spLocks noGrp="1" noRot="1" noChangeAspect="1" noChangeArrowheads="1" noTextEdit="1"/>
-          </p:cNvSpPr>
-          <p:nvPr>
-            <p:ph type="sldImg"/>
-          </p:nvPr>
-        </p:nvSpPr>
-        <p:spPr>
-          <a:ln/>
-        </p:spPr>
-      </p:sp>
-      <p:sp>
-        <p:nvSpPr>
-          <p:cNvPr id="54276" name="Rectangle 3"/>
-          <p:cNvSpPr>
-            <a:spLocks noGrp="1" noChangeArrowheads="1"/>
-          </p:cNvSpPr>
-          <p:nvPr>
-            <p:ph type="body" idx="1"/>
-          </p:nvPr>
-        </p:nvSpPr>
-        <p:spPr>
-          <a:noFill/>
-          <a:ln/>
-        </p:spPr>
-        <p:txBody>
-          <a:bodyPr/>
-          <a:lstStyle/>
-          <a:p>
-            <a:r>
-              <a:rPr lang="sv-SE" dirty="0"/>
-              <a:t>Windows </a:t>
-            </a:r>
-            <a:r>
-              <a:rPr lang="sv-SE" dirty="0" err="1"/>
-              <a:t>too</a:t>
-            </a:r>
-            <a:r>
-              <a:rPr lang="sv-SE" dirty="0"/>
-              <a:t> offers </a:t>
-            </a:r>
-            <a:r>
-              <a:rPr lang="sv-SE" dirty="0" err="1"/>
-              <a:t>synchronization</a:t>
-            </a:r>
-            <a:r>
-              <a:rPr lang="sv-SE" dirty="0"/>
-              <a:t> primitives, for </a:t>
-            </a:r>
-            <a:r>
-              <a:rPr lang="sv-SE" dirty="0" err="1"/>
-              <a:t>instance</a:t>
-            </a:r>
-            <a:r>
-              <a:rPr lang="sv-SE" dirty="0"/>
-              <a:t> </a:t>
-            </a:r>
-            <a:r>
-              <a:rPr lang="sv-SE" dirty="0" err="1"/>
-              <a:t>interrupt</a:t>
-            </a:r>
-            <a:r>
-              <a:rPr lang="sv-SE" dirty="0"/>
-              <a:t> masks to </a:t>
-            </a:r>
-            <a:r>
-              <a:rPr lang="sv-SE" dirty="0" err="1"/>
-              <a:t>protect</a:t>
-            </a:r>
-            <a:r>
-              <a:rPr lang="sv-SE" dirty="0"/>
-              <a:t> access to global </a:t>
-            </a:r>
-            <a:r>
-              <a:rPr lang="sv-SE" dirty="0" err="1"/>
-              <a:t>resources</a:t>
-            </a:r>
-            <a:r>
-              <a:rPr lang="sv-SE" dirty="0"/>
-              <a:t> on </a:t>
-            </a:r>
-            <a:r>
-              <a:rPr lang="sv-SE" dirty="0" err="1"/>
-              <a:t>uniprocessors</a:t>
-            </a:r>
-            <a:r>
-              <a:rPr lang="sv-SE" dirty="0"/>
-              <a:t> and </a:t>
-            </a:r>
-            <a:r>
-              <a:rPr lang="sv-SE" dirty="0" err="1"/>
-              <a:t>busy-wait</a:t>
-            </a:r>
-            <a:r>
-              <a:rPr lang="sv-SE" dirty="0"/>
-              <a:t> spinlocks for multiprocessors (</a:t>
-            </a:r>
-            <a:r>
-              <a:rPr lang="sv-SE" dirty="0" err="1"/>
-              <a:t>we</a:t>
-            </a:r>
-            <a:r>
-              <a:rPr lang="sv-SE" dirty="0"/>
-              <a:t> </a:t>
-            </a:r>
-            <a:r>
-              <a:rPr lang="sv-SE" dirty="0" err="1"/>
-              <a:t>have</a:t>
-            </a:r>
-            <a:r>
-              <a:rPr lang="sv-SE" dirty="0"/>
-              <a:t> </a:t>
-            </a:r>
-            <a:r>
-              <a:rPr lang="sv-SE" dirty="0" err="1"/>
-              <a:t>discussed</a:t>
-            </a:r>
-            <a:r>
-              <a:rPr lang="sv-SE" dirty="0"/>
-              <a:t> </a:t>
-            </a:r>
-            <a:r>
-              <a:rPr lang="sv-SE" dirty="0" err="1"/>
-              <a:t>before</a:t>
-            </a:r>
-            <a:r>
-              <a:rPr lang="sv-SE" dirty="0"/>
-              <a:t> </a:t>
-            </a:r>
-            <a:r>
-              <a:rPr lang="sv-SE" dirty="0" err="1"/>
-              <a:t>why</a:t>
-            </a:r>
-            <a:r>
-              <a:rPr lang="sv-SE" dirty="0"/>
-              <a:t> </a:t>
-            </a:r>
-            <a:r>
-              <a:rPr lang="sv-SE" dirty="0" err="1"/>
-              <a:t>disabling</a:t>
-            </a:r>
-            <a:r>
-              <a:rPr lang="sv-SE" dirty="0"/>
-              <a:t> </a:t>
-            </a:r>
-            <a:r>
-              <a:rPr lang="sv-SE" dirty="0" err="1"/>
-              <a:t>interrupts</a:t>
-            </a:r>
-            <a:r>
-              <a:rPr lang="sv-SE" dirty="0"/>
-              <a:t> on a </a:t>
-            </a:r>
-            <a:r>
-              <a:rPr lang="sv-SE" dirty="0" err="1"/>
-              <a:t>single</a:t>
-            </a:r>
-            <a:r>
-              <a:rPr lang="sv-SE" dirty="0"/>
-              <a:t> processor </a:t>
-            </a:r>
-            <a:r>
-              <a:rPr lang="sv-SE" dirty="0" err="1"/>
-              <a:t>might</a:t>
-            </a:r>
-            <a:r>
-              <a:rPr lang="sv-SE" dirty="0"/>
-              <a:t> be not </a:t>
-            </a:r>
-            <a:r>
-              <a:rPr lang="sv-SE" dirty="0" err="1"/>
-              <a:t>enough</a:t>
-            </a:r>
-            <a:r>
-              <a:rPr lang="sv-SE" dirty="0"/>
-              <a:t> to </a:t>
-            </a:r>
-            <a:r>
-              <a:rPr lang="sv-SE" dirty="0" err="1"/>
-              <a:t>have</a:t>
-            </a:r>
-            <a:r>
-              <a:rPr lang="sv-SE" dirty="0"/>
-              <a:t> valid solutions to the </a:t>
-            </a:r>
-            <a:r>
-              <a:rPr lang="sv-SE" dirty="0" err="1"/>
-              <a:t>critical</a:t>
-            </a:r>
-            <a:r>
-              <a:rPr lang="sv-SE" dirty="0"/>
-              <a:t> </a:t>
-            </a:r>
-            <a:r>
-              <a:rPr lang="sv-SE" dirty="0" err="1"/>
-              <a:t>section</a:t>
-            </a:r>
-            <a:r>
-              <a:rPr lang="sv-SE" dirty="0"/>
-              <a:t> problem). </a:t>
-            </a:r>
-            <a:r>
-              <a:rPr lang="sv-SE" dirty="0" err="1"/>
-              <a:t>Finally</a:t>
-            </a:r>
-            <a:r>
-              <a:rPr lang="sv-SE" dirty="0"/>
-              <a:t>, it </a:t>
-            </a:r>
-            <a:r>
-              <a:rPr lang="sv-SE" dirty="0" err="1"/>
-              <a:t>also</a:t>
-            </a:r>
-            <a:r>
-              <a:rPr lang="sv-SE" dirty="0"/>
-              <a:t> offers </a:t>
-            </a:r>
-            <a:r>
-              <a:rPr lang="sv-SE" dirty="0" err="1"/>
-              <a:t>objects</a:t>
-            </a:r>
-            <a:r>
-              <a:rPr lang="sv-SE" dirty="0"/>
-              <a:t> like </a:t>
-            </a:r>
-            <a:r>
-              <a:rPr lang="sv-SE" dirty="0" err="1"/>
-              <a:t>mutexes</a:t>
-            </a:r>
-            <a:r>
-              <a:rPr lang="sv-SE" dirty="0"/>
-              <a:t>, </a:t>
-            </a:r>
-            <a:r>
-              <a:rPr lang="sv-SE" dirty="0" err="1"/>
-              <a:t>semaphores</a:t>
-            </a:r>
-            <a:r>
-              <a:rPr lang="sv-SE" dirty="0"/>
-              <a:t> or to </a:t>
-            </a:r>
-            <a:r>
-              <a:rPr lang="sv-SE" dirty="0" err="1"/>
-              <a:t>provide</a:t>
-            </a:r>
-            <a:r>
-              <a:rPr lang="sv-SE" dirty="0"/>
-              <a:t> events (</a:t>
-            </a:r>
-            <a:r>
-              <a:rPr lang="sv-SE" dirty="0" err="1"/>
-              <a:t>similar</a:t>
-            </a:r>
-            <a:r>
-              <a:rPr lang="sv-SE" dirty="0"/>
-              <a:t> to </a:t>
-            </a:r>
-            <a:r>
-              <a:rPr lang="sv-SE" dirty="0" err="1"/>
-              <a:t>condition</a:t>
-            </a:r>
-            <a:r>
-              <a:rPr lang="sv-SE" dirty="0"/>
-              <a:t> </a:t>
-            </a:r>
-            <a:r>
-              <a:rPr lang="sv-SE" dirty="0" err="1"/>
-              <a:t>variables</a:t>
-            </a:r>
-            <a:r>
-              <a:rPr lang="sv-SE" dirty="0"/>
-              <a:t>).</a:t>
-            </a:r>
-          </a:p>
-        </p:txBody>
-      </p:sp>
-    </p:spTree>
-    <p:extLst>
-      <p:ext uri="{BB962C8B-B14F-4D97-AF65-F5344CB8AC3E}">
-        <p14:creationId xmlns:p14="http://schemas.microsoft.com/office/powerpoint/2010/main" val="3321594125"/>
-      </p:ext>
-    </p:extLst>
-  </p:cSld>
-  <p:clrMapOvr>
-    <a:masterClrMapping/>
-  </p:clrMapOvr>
-</p:notes>
-</file>
-
-<file path=ppt/notesSlides/notesSlide42.xml><?xml version="1.0" encoding="utf-8"?>
-<p:notes xmlns:a="http://schemas.openxmlformats.org/drawingml/2006/main" xmlns:r="http://schemas.openxmlformats.org/officeDocument/2006/relationships" xmlns:p="http://schemas.openxmlformats.org/presentationml/2006/main">
-  <p:cSld>
-    <p:spTree>
-      <p:nvGrpSpPr>
-        <p:cNvPr id="1" name=""/>
-        <p:cNvGrpSpPr/>
-        <p:nvPr/>
-      </p:nvGrpSpPr>
-      <p:grpSpPr>
-        <a:xfrm>
-          <a:off x="0" y="0"/>
-          <a:ext cx="0" cy="0"/>
-          <a:chOff x="0" y="0"/>
-          <a:chExt cx="0" cy="0"/>
-        </a:xfrm>
-      </p:grpSpPr>
-      <p:sp>
-        <p:nvSpPr>
-          <p:cNvPr id="56322" name="Rectangle 7"/>
-          <p:cNvSpPr>
-            <a:spLocks noGrp="1" noChangeArrowheads="1"/>
-          </p:cNvSpPr>
-          <p:nvPr>
-            <p:ph type="sldNum" sz="quarter" idx="5"/>
-          </p:nvPr>
-        </p:nvSpPr>
-        <p:spPr>
-          <a:noFill/>
-        </p:spPr>
-        <p:txBody>
-          <a:bodyPr/>
-          <a:lstStyle/>
-          <a:p>
-            <a:pPr marL="0" marR="0" lvl="0" indent="0" algn="r" defTabSz="914400" rtl="0" eaLnBrk="1" fontAlgn="auto" latinLnBrk="0" hangingPunct="1">
-              <a:lnSpc>
-                <a:spcPct val="100000"/>
-              </a:lnSpc>
-              <a:spcBef>
-                <a:spcPts val="0"/>
-              </a:spcBef>
-              <a:spcAft>
-                <a:spcPts val="0"/>
-              </a:spcAft>
-              <a:buClrTx/>
-              <a:buSzTx/>
-              <a:buFontTx/>
-              <a:buNone/>
-              <a:tabLst/>
-              <a:defRPr/>
-            </a:pPr>
-            <a:fld id="{4DB15479-77C4-4247-86C7-895882BE5E1E}" type="slidenum">
-              <a:rPr kumimoji="0" lang="en-US" sz="1200" b="0" i="0" u="none" strike="noStrike" kern="1200" cap="none" spc="0" normalizeH="0" baseline="0" noProof="0" smtClean="0">
-                <a:ln>
-                  <a:noFill/>
-                </a:ln>
-                <a:solidFill>
-                  <a:prstClr val="black"/>
-                </a:solidFill>
-                <a:effectLst/>
-                <a:uLnTx/>
-                <a:uFillTx/>
-                <a:latin typeface="Calibri" panose="020F0502020204030204"/>
-                <a:ea typeface="+mn-ea"/>
-                <a:cs typeface="+mn-cs"/>
-              </a:rPr>
-              <a:pPr marL="0" marR="0" lvl="0" indent="0" algn="r" defTabSz="914400" rtl="0" eaLnBrk="1" fontAlgn="auto" latinLnBrk="0" hangingPunct="1">
-                <a:lnSpc>
-                  <a:spcPct val="100000"/>
-                </a:lnSpc>
-                <a:spcBef>
-                  <a:spcPts val="0"/>
-                </a:spcBef>
-                <a:spcAft>
-                  <a:spcPts val="0"/>
-                </a:spcAft>
-                <a:buClrTx/>
-                <a:buSzTx/>
-                <a:buFontTx/>
-                <a:buNone/>
-                <a:tabLst/>
-                <a:defRPr/>
-              </a:pPr>
-              <a:t>43</a:t>
-            </a:fld>
-            <a:endParaRPr kumimoji="0" lang="en-US" sz="1200" b="0" i="0" u="none" strike="noStrike" kern="1200" cap="none" spc="0" normalizeH="0" baseline="0" noProof="0">
-              <a:ln>
-                <a:noFill/>
-              </a:ln>
-              <a:solidFill>
-                <a:prstClr val="black"/>
-              </a:solidFill>
-              <a:effectLst/>
-              <a:uLnTx/>
-              <a:uFillTx/>
-              <a:latin typeface="Calibri" panose="020F0502020204030204"/>
-              <a:ea typeface="+mn-ea"/>
-              <a:cs typeface="+mn-cs"/>
-            </a:endParaRPr>
-          </a:p>
-        </p:txBody>
-      </p:sp>
-      <p:sp>
-        <p:nvSpPr>
           <p:cNvPr id="56323" name="Rectangle 2"/>
           <p:cNvSpPr>
             <a:spLocks noGrp="1" noRot="1" noChangeAspect="1" noChangeArrowheads="1" noTextEdit="1"/>
@@ -6780,6 +6354,93 @@
     <p:extLst>
       <p:ext uri="{BB962C8B-B14F-4D97-AF65-F5344CB8AC3E}">
         <p14:creationId xmlns:p14="http://schemas.microsoft.com/office/powerpoint/2010/main" val="1603240883"/>
+      </p:ext>
+    </p:extLst>
+  </p:cSld>
+  <p:clrMapOvr>
+    <a:masterClrMapping/>
+  </p:clrMapOvr>
+</p:notes>
+</file>
+
+<file path=ppt/notesSlides/notesSlide42.xml><?xml version="1.0" encoding="utf-8"?>
+<p:notes xmlns:a="http://schemas.openxmlformats.org/drawingml/2006/main" xmlns:r="http://schemas.openxmlformats.org/officeDocument/2006/relationships" xmlns:p="http://schemas.openxmlformats.org/presentationml/2006/main">
+  <p:cSld>
+    <p:spTree>
+      <p:nvGrpSpPr>
+        <p:cNvPr id="1" name=""/>
+        <p:cNvGrpSpPr/>
+        <p:nvPr/>
+      </p:nvGrpSpPr>
+      <p:grpSpPr>
+        <a:xfrm>
+          <a:off x="0" y="0"/>
+          <a:ext cx="0" cy="0"/>
+          <a:chOff x="0" y="0"/>
+          <a:chExt cx="0" cy="0"/>
+        </a:xfrm>
+      </p:grpSpPr>
+      <p:sp>
+        <p:nvSpPr>
+          <p:cNvPr id="2" name="Slide Image Placeholder 1"/>
+          <p:cNvSpPr>
+            <a:spLocks noGrp="1" noRot="1" noChangeAspect="1"/>
+          </p:cNvSpPr>
+          <p:nvPr>
+            <p:ph type="sldImg"/>
+          </p:nvPr>
+        </p:nvSpPr>
+        <p:spPr/>
+      </p:sp>
+      <p:sp>
+        <p:nvSpPr>
+          <p:cNvPr id="3" name="Notes Placeholder 2"/>
+          <p:cNvSpPr>
+            <a:spLocks noGrp="1"/>
+          </p:cNvSpPr>
+          <p:nvPr>
+            <p:ph type="body" idx="1"/>
+          </p:nvPr>
+        </p:nvSpPr>
+        <p:spPr/>
+        <p:txBody>
+          <a:bodyPr/>
+          <a:lstStyle/>
+          <a:p>
+            <a:r>
+              <a:rPr lang="en-US" dirty="0"/>
+              <a:t>no</a:t>
+            </a:r>
+          </a:p>
+        </p:txBody>
+      </p:sp>
+      <p:sp>
+        <p:nvSpPr>
+          <p:cNvPr id="4" name="Slide Number Placeholder 3"/>
+          <p:cNvSpPr>
+            <a:spLocks noGrp="1"/>
+          </p:cNvSpPr>
+          <p:nvPr>
+            <p:ph type="sldNum" sz="quarter" idx="5"/>
+          </p:nvPr>
+        </p:nvSpPr>
+        <p:spPr/>
+        <p:txBody>
+          <a:bodyPr/>
+          <a:lstStyle/>
+          <a:p>
+            <a:fld id="{20BC1079-C5C6-1A45-8E7E-B20B607B09A1}" type="slidenum">
+              <a:rPr lang="en-US" smtClean="0"/>
+              <a:t>44</a:t>
+            </a:fld>
+            <a:endParaRPr lang="en-US"/>
+          </a:p>
+        </p:txBody>
+      </p:sp>
+    </p:spTree>
+    <p:extLst>
+      <p:ext uri="{BB962C8B-B14F-4D97-AF65-F5344CB8AC3E}">
+        <p14:creationId xmlns:p14="http://schemas.microsoft.com/office/powerpoint/2010/main" val="4181208129"/>
       </p:ext>
     </p:extLst>
   </p:cSld>
@@ -6835,8 +6496,14 @@
           <a:p>
             <a:r>
               <a:rPr lang="en-US" dirty="0"/>
-              <a:t>no</a:t>
-            </a:r>
+              <a:t>Yes</a:t>
+            </a:r>
+          </a:p>
+          <a:p>
+            <a:endParaRPr lang="en-US" dirty="0"/>
+          </a:p>
+          <a:p>
+            <a:endParaRPr lang="en-US" dirty="0"/>
           </a:p>
         </p:txBody>
       </p:sp>
@@ -6866,7 +6533,7 @@
     </p:spTree>
     <p:extLst>
       <p:ext uri="{BB962C8B-B14F-4D97-AF65-F5344CB8AC3E}">
-        <p14:creationId xmlns:p14="http://schemas.microsoft.com/office/powerpoint/2010/main" val="4181208129"/>
+        <p14:creationId xmlns:p14="http://schemas.microsoft.com/office/powerpoint/2010/main" val="1108123815"/>
       </p:ext>
     </p:extLst>
   </p:cSld>
@@ -6922,7 +6589,7 @@
           <a:p>
             <a:r>
               <a:rPr lang="en-US" dirty="0"/>
-              <a:t>a b c a b c</a:t>
+              <a:t>2</a:t>
             </a:r>
           </a:p>
         </p:txBody>
@@ -6953,7 +6620,7 @@
     </p:spTree>
     <p:extLst>
       <p:ext uri="{BB962C8B-B14F-4D97-AF65-F5344CB8AC3E}">
-        <p14:creationId xmlns:p14="http://schemas.microsoft.com/office/powerpoint/2010/main" val="3114456274"/>
+        <p14:creationId xmlns:p14="http://schemas.microsoft.com/office/powerpoint/2010/main" val="1756688380"/>
       </p:ext>
     </p:extLst>
   </p:cSld>
@@ -7008,8 +6675,8 @@
           <a:lstStyle/>
           <a:p>
             <a:r>
-              <a:rPr lang="en-US" dirty="0"/>
-              <a:t>Yes</a:t>
+              <a:rPr lang="en-US"/>
+              <a:t>No</a:t>
             </a:r>
           </a:p>
         </p:txBody>
@@ -7032,180 +6699,6 @@
             <a:fld id="{20BC1079-C5C6-1A45-8E7E-B20B607B09A1}" type="slidenum">
               <a:rPr lang="en-US" smtClean="0"/>
               <a:t>47</a:t>
-            </a:fld>
-            <a:endParaRPr lang="en-US"/>
-          </a:p>
-        </p:txBody>
-      </p:sp>
-    </p:spTree>
-    <p:extLst>
-      <p:ext uri="{BB962C8B-B14F-4D97-AF65-F5344CB8AC3E}">
-        <p14:creationId xmlns:p14="http://schemas.microsoft.com/office/powerpoint/2010/main" val="1108123815"/>
-      </p:ext>
-    </p:extLst>
-  </p:cSld>
-  <p:clrMapOvr>
-    <a:masterClrMapping/>
-  </p:clrMapOvr>
-</p:notes>
-</file>
-
-<file path=ppt/notesSlides/notesSlide46.xml><?xml version="1.0" encoding="utf-8"?>
-<p:notes xmlns:a="http://schemas.openxmlformats.org/drawingml/2006/main" xmlns:r="http://schemas.openxmlformats.org/officeDocument/2006/relationships" xmlns:p="http://schemas.openxmlformats.org/presentationml/2006/main">
-  <p:cSld>
-    <p:spTree>
-      <p:nvGrpSpPr>
-        <p:cNvPr id="1" name=""/>
-        <p:cNvGrpSpPr/>
-        <p:nvPr/>
-      </p:nvGrpSpPr>
-      <p:grpSpPr>
-        <a:xfrm>
-          <a:off x="0" y="0"/>
-          <a:ext cx="0" cy="0"/>
-          <a:chOff x="0" y="0"/>
-          <a:chExt cx="0" cy="0"/>
-        </a:xfrm>
-      </p:grpSpPr>
-      <p:sp>
-        <p:nvSpPr>
-          <p:cNvPr id="2" name="Slide Image Placeholder 1"/>
-          <p:cNvSpPr>
-            <a:spLocks noGrp="1" noRot="1" noChangeAspect="1"/>
-          </p:cNvSpPr>
-          <p:nvPr>
-            <p:ph type="sldImg"/>
-          </p:nvPr>
-        </p:nvSpPr>
-        <p:spPr/>
-      </p:sp>
-      <p:sp>
-        <p:nvSpPr>
-          <p:cNvPr id="3" name="Notes Placeholder 2"/>
-          <p:cNvSpPr>
-            <a:spLocks noGrp="1"/>
-          </p:cNvSpPr>
-          <p:nvPr>
-            <p:ph type="body" idx="1"/>
-          </p:nvPr>
-        </p:nvSpPr>
-        <p:spPr/>
-        <p:txBody>
-          <a:bodyPr/>
-          <a:lstStyle/>
-          <a:p>
-            <a:r>
-              <a:rPr lang="en-US" dirty="0"/>
-              <a:t>2</a:t>
-            </a:r>
-          </a:p>
-        </p:txBody>
-      </p:sp>
-      <p:sp>
-        <p:nvSpPr>
-          <p:cNvPr id="4" name="Slide Number Placeholder 3"/>
-          <p:cNvSpPr>
-            <a:spLocks noGrp="1"/>
-          </p:cNvSpPr>
-          <p:nvPr>
-            <p:ph type="sldNum" sz="quarter" idx="5"/>
-          </p:nvPr>
-        </p:nvSpPr>
-        <p:spPr/>
-        <p:txBody>
-          <a:bodyPr/>
-          <a:lstStyle/>
-          <a:p>
-            <a:fld id="{20BC1079-C5C6-1A45-8E7E-B20B607B09A1}" type="slidenum">
-              <a:rPr lang="en-US" smtClean="0"/>
-              <a:t>48</a:t>
-            </a:fld>
-            <a:endParaRPr lang="en-US"/>
-          </a:p>
-        </p:txBody>
-      </p:sp>
-    </p:spTree>
-    <p:extLst>
-      <p:ext uri="{BB962C8B-B14F-4D97-AF65-F5344CB8AC3E}">
-        <p14:creationId xmlns:p14="http://schemas.microsoft.com/office/powerpoint/2010/main" val="1756688380"/>
-      </p:ext>
-    </p:extLst>
-  </p:cSld>
-  <p:clrMapOvr>
-    <a:masterClrMapping/>
-  </p:clrMapOvr>
-</p:notes>
-</file>
-
-<file path=ppt/notesSlides/notesSlide47.xml><?xml version="1.0" encoding="utf-8"?>
-<p:notes xmlns:a="http://schemas.openxmlformats.org/drawingml/2006/main" xmlns:r="http://schemas.openxmlformats.org/officeDocument/2006/relationships" xmlns:p="http://schemas.openxmlformats.org/presentationml/2006/main">
-  <p:cSld>
-    <p:spTree>
-      <p:nvGrpSpPr>
-        <p:cNvPr id="1" name=""/>
-        <p:cNvGrpSpPr/>
-        <p:nvPr/>
-      </p:nvGrpSpPr>
-      <p:grpSpPr>
-        <a:xfrm>
-          <a:off x="0" y="0"/>
-          <a:ext cx="0" cy="0"/>
-          <a:chOff x="0" y="0"/>
-          <a:chExt cx="0" cy="0"/>
-        </a:xfrm>
-      </p:grpSpPr>
-      <p:sp>
-        <p:nvSpPr>
-          <p:cNvPr id="2" name="Slide Image Placeholder 1"/>
-          <p:cNvSpPr>
-            <a:spLocks noGrp="1" noRot="1" noChangeAspect="1"/>
-          </p:cNvSpPr>
-          <p:nvPr>
-            <p:ph type="sldImg"/>
-          </p:nvPr>
-        </p:nvSpPr>
-        <p:spPr/>
-      </p:sp>
-      <p:sp>
-        <p:nvSpPr>
-          <p:cNvPr id="3" name="Notes Placeholder 2"/>
-          <p:cNvSpPr>
-            <a:spLocks noGrp="1"/>
-          </p:cNvSpPr>
-          <p:nvPr>
-            <p:ph type="body" idx="1"/>
-          </p:nvPr>
-        </p:nvSpPr>
-        <p:spPr/>
-        <p:txBody>
-          <a:bodyPr/>
-          <a:lstStyle/>
-          <a:p>
-            <a:r>
-              <a:rPr lang="en-US"/>
-              <a:t>No</a:t>
-            </a:r>
-          </a:p>
-        </p:txBody>
-      </p:sp>
-      <p:sp>
-        <p:nvSpPr>
-          <p:cNvPr id="4" name="Slide Number Placeholder 3"/>
-          <p:cNvSpPr>
-            <a:spLocks noGrp="1"/>
-          </p:cNvSpPr>
-          <p:nvPr>
-            <p:ph type="sldNum" sz="quarter" idx="5"/>
-          </p:nvPr>
-        </p:nvSpPr>
-        <p:spPr/>
-        <p:txBody>
-          <a:bodyPr/>
-          <a:lstStyle/>
-          <a:p>
-            <a:fld id="{20BC1079-C5C6-1A45-8E7E-B20B607B09A1}" type="slidenum">
-              <a:rPr lang="en-US" smtClean="0"/>
-              <a:t>49</a:t>
             </a:fld>
             <a:endParaRPr lang="en-US"/>
           </a:p>
@@ -7417,7 +6910,7 @@
           <a:p>
             <a:r>
               <a:rPr lang="en-US" dirty="0"/>
-              <a:t>Let’s also assume A and B run in parallel, each on its core. Their code includes three instructions to update S.</a:t>
+              <a:t>Let’s also assume A and B run in parallel, each on its core. Their code includes three operations to update S.</a:t>
             </a:r>
           </a:p>
           <a:p>
@@ -7624,7 +7117,7 @@
           <a:p>
             <a:r>
               <a:rPr lang="en-US" dirty="0"/>
-              <a:t>Since we will look into whether 2 or more concurrent threads are correctly handling shared variables, let's introduce a system model for the critical section problem.</a:t>
+              <a:t>Since we will look into whether 2 or more concurrent threads are correctly handling shared variables, let's introduce a system model for the critical-section problem.</a:t>
             </a:r>
           </a:p>
           <a:p>
@@ -7728,7 +7221,7 @@
           <a:p>
             <a:r>
               <a:rPr lang="en-US" dirty="0"/>
-              <a:t>Notice that we do not make any assumption about the duration of the reminder section of a thread. A thread can stay there for as long as it needs. The duration of the reminder section is NOT bounded in time.</a:t>
+              <a:t>Notice that we do not make any assumption about the duration of the remainder section of a thread. A thread can stay there for as long as it needs. The duration of the remainder section is NOT bounded in time.</a:t>
             </a:r>
           </a:p>
           <a:p>
@@ -7867,6 +7360,12 @@
             <a:r>
               <a:rPr lang="en-US" dirty="0"/>
               <a:t>As you can see, only one thread at a time can enter the critical region. If a thread B tries to enter it when another thread A is in it, then B waits. </a:t>
+            </a:r>
+          </a:p>
+          <a:p>
+            <a:r>
+              <a:rPr lang="en-US" dirty="0"/>
+              <a:t>Note here the term blocked refers to the fact that Process B cannot execute its critical region, the process/thread is not necessarily blocked from the perspective of the OS (e.g., it might busy-waiting).</a:t>
             </a:r>
           </a:p>
         </p:txBody>
@@ -9047,10 +8546,7 @@
           <a:bodyPr/>
           <a:lstStyle/>
           <a:p>
-            <a:r>
-              <a:rPr lang="en-US"/>
-              <a:t>Operating Systems - Processes</a:t>
-            </a:r>
+            <a:endParaRPr lang="en-US"/>
           </a:p>
         </p:txBody>
       </p:sp>
@@ -9217,10 +8713,7 @@
           <a:bodyPr/>
           <a:lstStyle/>
           <a:p>
-            <a:r>
-              <a:rPr lang="en-US"/>
-              <a:t>Operating Systems - Processes</a:t>
-            </a:r>
+            <a:endParaRPr lang="en-US"/>
           </a:p>
         </p:txBody>
       </p:sp>
@@ -9464,10 +8957,7 @@
           <a:bodyPr/>
           <a:lstStyle/>
           <a:p>
-            <a:r>
-              <a:rPr lang="en-US"/>
-              <a:t>Operating Systems - Processes</a:t>
-            </a:r>
+            <a:endParaRPr lang="en-US"/>
           </a:p>
         </p:txBody>
       </p:sp>
@@ -9695,10 +9185,7 @@
           <a:bodyPr/>
           <a:lstStyle/>
           <a:p>
-            <a:r>
-              <a:rPr lang="en-US"/>
-              <a:t>Operating Systems - Processes</a:t>
-            </a:r>
+            <a:endParaRPr lang="en-US"/>
           </a:p>
         </p:txBody>
       </p:sp>
@@ -10061,10 +9548,7 @@
           <a:bodyPr/>
           <a:lstStyle/>
           <a:p>
-            <a:r>
-              <a:rPr lang="en-US"/>
-              <a:t>Operating Systems - Processes</a:t>
-            </a:r>
+            <a:endParaRPr lang="en-US"/>
           </a:p>
         </p:txBody>
       </p:sp>
@@ -10180,10 +9664,7 @@
           <a:bodyPr/>
           <a:lstStyle/>
           <a:p>
-            <a:r>
-              <a:rPr lang="en-US"/>
-              <a:t>Operating Systems - Processes</a:t>
-            </a:r>
+            <a:endParaRPr lang="en-US"/>
           </a:p>
         </p:txBody>
       </p:sp>
@@ -10476,10 +9957,7 @@
           <a:bodyPr/>
           <a:lstStyle/>
           <a:p>
-            <a:r>
-              <a:rPr lang="en-US"/>
-              <a:t>Operating Systems - Processes</a:t>
-            </a:r>
+            <a:endParaRPr lang="en-US"/>
           </a:p>
         </p:txBody>
       </p:sp>
@@ -10753,10 +10231,7 @@
           <a:bodyPr/>
           <a:lstStyle/>
           <a:p>
-            <a:r>
-              <a:rPr lang="en-US"/>
-              <a:t>Operating Systems - Processes</a:t>
-            </a:r>
+            <a:endParaRPr lang="en-US"/>
           </a:p>
         </p:txBody>
       </p:sp>
@@ -11007,10 +10482,6 @@
           <a:bodyPr/>
           <a:lstStyle/>
           <a:p>
-            <a:r>
-              <a:rPr lang="en-US"/>
-              <a:t>Operating Systems - Processes</a:t>
-            </a:r>
             <a:endParaRPr lang="en-US" dirty="0"/>
           </a:p>
         </p:txBody>
@@ -11178,10 +10649,7 @@
           <a:bodyPr/>
           <a:lstStyle/>
           <a:p>
-            <a:r>
-              <a:rPr lang="en-US"/>
-              <a:t>Operating Systems - Processes</a:t>
-            </a:r>
+            <a:endParaRPr lang="en-US"/>
           </a:p>
         </p:txBody>
       </p:sp>
@@ -11358,10 +10826,7 @@
           <a:bodyPr/>
           <a:lstStyle/>
           <a:p>
-            <a:r>
-              <a:rPr lang="en-US"/>
-              <a:t>Operating Systems - Processes</a:t>
-            </a:r>
+            <a:endParaRPr lang="en-US"/>
           </a:p>
         </p:txBody>
       </p:sp>
@@ -14031,10 +13496,7 @@
             </a:lvl1pPr>
           </a:lstStyle>
           <a:p>
-            <a:r>
-              <a:rPr lang="en-US"/>
-              <a:t>Operating Systems - Processes</a:t>
-            </a:r>
+            <a:endParaRPr lang="en-US"/>
           </a:p>
         </p:txBody>
       </p:sp>
@@ -14101,7 +13563,7 @@
     <p:sldLayoutId id="2147483678" r:id="rId11"/>
     <p:sldLayoutId id="2147483679" r:id="rId12"/>
   </p:sldLayoutIdLst>
-  <p:hf hdr="0"/>
+  <p:hf hdr="0" ftr="0"/>
   <p:txStyles>
     <p:titleStyle>
       <a:lvl1pPr algn="l" defTabSz="685800" rtl="0" eaLnBrk="1" latinLnBrk="0" hangingPunct="1">
@@ -14857,6 +14319,144 @@
             <a:r>
               <a:rPr lang="en-US"/>
               <a:t>Vincenzo Gulisano</a:t>
+            </a:r>
+          </a:p>
+        </p:txBody>
+      </p:sp>
+      <p:sp>
+        <p:nvSpPr>
+          <p:cNvPr id="5" name="Oval 4">
+            <a:extLst>
+              <a:ext uri="{FF2B5EF4-FFF2-40B4-BE49-F238E27FC236}">
+                <a16:creationId xmlns:a16="http://schemas.microsoft.com/office/drawing/2014/main" id="{8F193F89-2B2A-F503-659E-2121CBF490EA}"/>
+              </a:ext>
+            </a:extLst>
+          </p:cNvPr>
+          <p:cNvSpPr/>
+          <p:nvPr/>
+        </p:nvSpPr>
+        <p:spPr>
+          <a:xfrm>
+            <a:off x="5486400" y="4302541"/>
+            <a:ext cx="1413164" cy="718346"/>
+          </a:xfrm>
+          <a:prstGeom prst="ellipse">
+            <a:avLst/>
+          </a:prstGeom>
+          <a:noFill/>
+          <a:ln w="38100">
+            <a:solidFill>
+              <a:srgbClr val="FF0000"/>
+            </a:solidFill>
+          </a:ln>
+        </p:spPr>
+        <p:style>
+          <a:lnRef idx="2">
+            <a:schemeClr val="accent1">
+              <a:shade val="15000"/>
+            </a:schemeClr>
+          </a:lnRef>
+          <a:fillRef idx="1">
+            <a:schemeClr val="accent1"/>
+          </a:fillRef>
+          <a:effectRef idx="0">
+            <a:schemeClr val="accent1"/>
+          </a:effectRef>
+          <a:fontRef idx="minor">
+            <a:schemeClr val="lt1"/>
+          </a:fontRef>
+        </p:style>
+        <p:txBody>
+          <a:bodyPr rtlCol="0" anchor="ctr"/>
+          <a:lstStyle/>
+          <a:p>
+            <a:pPr algn="ctr"/>
+            <a:endParaRPr lang="en-US" dirty="0"/>
+          </a:p>
+        </p:txBody>
+      </p:sp>
+      <p:cxnSp>
+        <p:nvCxnSpPr>
+          <p:cNvPr id="9" name="Straight Arrow Connector 8">
+            <a:extLst>
+              <a:ext uri="{FF2B5EF4-FFF2-40B4-BE49-F238E27FC236}">
+                <a16:creationId xmlns:a16="http://schemas.microsoft.com/office/drawing/2014/main" id="{CEDB8B35-A812-07F7-6CA4-86633FE784A2}"/>
+              </a:ext>
+            </a:extLst>
+          </p:cNvPr>
+          <p:cNvCxnSpPr>
+            <a:cxnSpLocks/>
+            <a:stCxn id="5" idx="5"/>
+            <a:endCxn id="13" idx="1"/>
+          </p:cNvCxnSpPr>
+          <p:nvPr/>
+        </p:nvCxnSpPr>
+        <p:spPr>
+          <a:xfrm>
+            <a:off x="6692611" y="4915688"/>
+            <a:ext cx="1148366" cy="1099492"/>
+          </a:xfrm>
+          <a:prstGeom prst="straightConnector1">
+            <a:avLst/>
+          </a:prstGeom>
+          <a:ln w="38100">
+            <a:solidFill>
+              <a:srgbClr val="FF0000"/>
+            </a:solidFill>
+            <a:headEnd type="triangle" w="lg" len="lg"/>
+            <a:tailEnd type="none" w="med" len="med"/>
+          </a:ln>
+        </p:spPr>
+        <p:style>
+          <a:lnRef idx="1">
+            <a:schemeClr val="accent1"/>
+          </a:lnRef>
+          <a:fillRef idx="0">
+            <a:schemeClr val="accent1"/>
+          </a:fillRef>
+          <a:effectRef idx="0">
+            <a:schemeClr val="accent1"/>
+          </a:effectRef>
+          <a:fontRef idx="minor">
+            <a:schemeClr val="tx1"/>
+          </a:fontRef>
+        </p:style>
+      </p:cxnSp>
+      <p:sp>
+        <p:nvSpPr>
+          <p:cNvPr id="13" name="TextBox 12">
+            <a:extLst>
+              <a:ext uri="{FF2B5EF4-FFF2-40B4-BE49-F238E27FC236}">
+                <a16:creationId xmlns:a16="http://schemas.microsoft.com/office/drawing/2014/main" id="{BA0CB9DF-8358-95D5-8A1E-F70AA597FB71}"/>
+              </a:ext>
+            </a:extLst>
+          </p:cNvPr>
+          <p:cNvSpPr txBox="1"/>
+          <p:nvPr/>
+        </p:nvSpPr>
+        <p:spPr>
+          <a:xfrm>
+            <a:off x="7840977" y="5415015"/>
+            <a:ext cx="4304131" cy="1200329"/>
+          </a:xfrm>
+          <a:prstGeom prst="rect">
+            <a:avLst/>
+          </a:prstGeom>
+          <a:noFill/>
+        </p:spPr>
+        <p:txBody>
+          <a:bodyPr wrap="square" rtlCol="0">
+            <a:spAutoFit/>
+          </a:bodyPr>
+          <a:lstStyle/>
+          <a:p>
+            <a:r>
+              <a:rPr lang="en-US" dirty="0">
+                <a:solidFill>
+                  <a:srgbClr val="FF0000"/>
+                </a:solidFill>
+              </a:rPr>
+              <a:t>Note: ”blocked” here means it cannot execute its critical region but does not imply the process (from the OS perspective) is blocked, it might be busy-waiting!</a:t>
             </a:r>
           </a:p>
         </p:txBody>
@@ -16021,7 +15621,7 @@
             <a:pPr lvl="1"/>
             <a:r>
               <a:rPr lang="en-US" sz="2000" dirty="0"/>
-              <a:t>Can we find an example showing it is not? then it is NOT valid.</a:t>
+              <a:t>Can we find an example showing it is not? Then it is NOT valid.</a:t>
             </a:r>
           </a:p>
           <a:p>
@@ -16487,25 +16087,8 @@
                   </a:schemeClr>
                 </a:solidFill>
               </a:rPr>
-              <a:t>//</a:t>
-            </a:r>
-            <a:r>
-              <a:rPr lang="en-US" sz="2400" dirty="0" err="1">
-                <a:solidFill>
-                  <a:schemeClr val="bg1">
-                    <a:lumMod val="50000"/>
-                  </a:schemeClr>
-                </a:solidFill>
-              </a:rPr>
-              <a:t>busywait</a:t>
-            </a:r>
-            <a:endParaRPr lang="en-US" sz="2400" dirty="0">
-              <a:solidFill>
-                <a:schemeClr val="bg1">
-                  <a:lumMod val="50000"/>
-                </a:schemeClr>
-              </a:solidFill>
-            </a:endParaRPr>
+              <a:t>//busy-wait</a:t>
+            </a:r>
           </a:p>
           <a:p>
             <a:pPr marL="457200" indent="-457200">
@@ -17325,7 +16908,7 @@
             <a:lstStyle/>
             <a:p>
               <a:r>
-                <a:rPr lang="en-US" sz="1600">
+                <a:rPr lang="en-US" sz="1600" dirty="0">
                   <a:solidFill>
                     <a:prstClr val="black"/>
                   </a:solidFill>
@@ -17333,14 +16916,30 @@
                 <a:t>sees</a:t>
               </a:r>
               <a:r>
-                <a:rPr lang="en-US" sz="1600" i="1">
+                <a:rPr lang="en-US" sz="1600" i="1" dirty="0">
                   <a:solidFill>
                     <a:prstClr val="black"/>
                   </a:solidFill>
                 </a:rPr>
-                <a:t>  flagB == false and completes line 4</a:t>
+                <a:t>  </a:t>
               </a:r>
-              <a:endParaRPr lang="en-US" sz="1600">
+              <a:r>
+                <a:rPr lang="en-US" sz="1600" i="1" dirty="0" err="1">
+                  <a:solidFill>
+                    <a:prstClr val="black"/>
+                  </a:solidFill>
+                </a:rPr>
+                <a:t>flagB</a:t>
+              </a:r>
+              <a:r>
+                <a:rPr lang="en-US" sz="1600" i="1" dirty="0">
+                  <a:solidFill>
+                    <a:prstClr val="black"/>
+                  </a:solidFill>
+                </a:rPr>
+                <a:t> == false and completes line 4</a:t>
+              </a:r>
+              <a:endParaRPr lang="en-US" sz="1600" dirty="0">
                 <a:solidFill>
                   <a:srgbClr val="C00000"/>
                 </a:solidFill>
@@ -21071,7 +20670,7 @@
                   </a:schemeClr>
                 </a:solidFill>
               </a:rPr>
-              <a:t>The Critical Section problem</a:t>
+              <a:t>The critical-section problem</a:t>
             </a:r>
           </a:p>
           <a:p>
@@ -21543,27 +21142,8 @@
                 </a:solidFill>
                 <a:sym typeface="Symbol" pitchFamily="18" charset="2"/>
               </a:rPr>
-              <a:t>//</a:t>
-            </a:r>
-            <a:r>
-              <a:rPr lang="en-US" sz="2200" dirty="0" err="1">
-                <a:solidFill>
-                  <a:schemeClr val="bg1">
-                    <a:lumMod val="65000"/>
-                  </a:schemeClr>
-                </a:solidFill>
-                <a:sym typeface="Symbol" pitchFamily="18" charset="2"/>
-              </a:rPr>
-              <a:t>busywait</a:t>
-            </a:r>
-            <a:endParaRPr lang="en-US" sz="2200" dirty="0">
-              <a:solidFill>
-                <a:schemeClr val="bg1">
-                  <a:lumMod val="65000"/>
-                </a:schemeClr>
-              </a:solidFill>
-              <a:sym typeface="Symbol" pitchFamily="18" charset="2"/>
-            </a:endParaRPr>
+              <a:t>//busy-wait</a:t>
+            </a:r>
           </a:p>
           <a:p>
             <a:pPr marL="457200" indent="-457200">
@@ -24601,7 +24181,7 @@
             </a:br>
             <a:r>
               <a:rPr lang="en-US" dirty="0"/>
-              <a:t>- Both for part 1 and part 2</a:t>
+              <a:t>- This is for both lectures on synchronization</a:t>
             </a:r>
           </a:p>
         </p:txBody>
@@ -24625,7 +24205,15 @@
           <a:p>
             <a:r>
               <a:rPr lang="en-US" dirty="0"/>
-              <a:t>Chapter 2.4.1-2.4.6, </a:t>
+              <a:t>Chapter 2.3.7-2.3.9, 2.3.11, </a:t>
+            </a:r>
+            <a:r>
+              <a:rPr lang="en-GB" dirty="0"/>
+              <a:t>6.3, </a:t>
+            </a:r>
+            <a:r>
+              <a:rPr lang="en-US" dirty="0"/>
+              <a:t>2.4.1-2.4.6, </a:t>
             </a:r>
             <a:r>
               <a:rPr lang="en-GB" dirty="0"/>
@@ -24633,19 +24221,8 @@
             </a:r>
             <a:r>
               <a:rPr lang="en-US" dirty="0"/>
-              <a:t>; </a:t>
-            </a:r>
-          </a:p>
-          <a:p>
-            <a:r>
-              <a:rPr lang="en-US" dirty="0"/>
-              <a:t>Quicker reading, for awareness, of sections 2.3.7-2.3.9, 2.3.11, </a:t>
-            </a:r>
-            <a:r>
-              <a:rPr lang="en-GB"/>
-              <a:t>6.3</a:t>
-            </a:r>
-            <a:endParaRPr lang="en-US" dirty="0"/>
+              <a:t>;</a:t>
+            </a:r>
           </a:p>
         </p:txBody>
       </p:sp>
@@ -26396,7 +25973,7 @@
                   </a:schemeClr>
                 </a:solidFill>
               </a:rPr>
-              <a:t>The Critical Section problem</a:t>
+              <a:t>The critical-section problem</a:t>
             </a:r>
           </a:p>
           <a:p>
@@ -27324,11 +26901,7 @@
             </a:r>
             <a:r>
               <a:rPr lang="en-US" i="1" dirty="0"/>
-              <a:t>check </a:t>
-            </a:r>
-            <a:r>
-              <a:rPr lang="en-US" i="1" dirty="0" err="1"/>
-              <a:t>order&amp;competition</a:t>
+              <a:t>check order &amp; competition</a:t>
             </a:r>
             <a:r>
               <a:rPr lang="en-US" dirty="0"/>
@@ -27445,10 +27018,10 @@
         </p:nvGrpSpPr>
         <p:grpSpPr>
           <a:xfrm>
-            <a:off x="2657546" y="4149455"/>
-            <a:ext cx="3190232" cy="307777"/>
-            <a:chOff x="129546" y="6241197"/>
-            <a:chExt cx="3190232" cy="307777"/>
+            <a:off x="886820" y="4986027"/>
+            <a:ext cx="4708714" cy="523220"/>
+            <a:chOff x="-318200" y="6574745"/>
+            <a:chExt cx="4708714" cy="523220"/>
           </a:xfrm>
         </p:grpSpPr>
         <p:sp>
@@ -27459,8 +27032,8 @@
           </p:nvSpPr>
           <p:spPr>
             <a:xfrm>
-              <a:off x="129546" y="6241197"/>
-              <a:ext cx="3190232" cy="307777"/>
+              <a:off x="435649" y="6574745"/>
+              <a:ext cx="3954865" cy="523220"/>
             </a:xfrm>
             <a:prstGeom prst="rect">
               <a:avLst/>
@@ -27479,12 +27052,12 @@
             <a:lstStyle/>
             <a:p>
               <a:r>
-                <a:rPr lang="en-US" sz="1400" dirty="0">
+                <a:rPr lang="en-US" sz="2800" dirty="0">
                   <a:solidFill>
                     <a:prstClr val="black"/>
                   </a:solidFill>
                 </a:rPr>
-                <a:t> -&gt; ,                    denote ”happened before</a:t>
+                <a:t>denotes happened before</a:t>
               </a:r>
             </a:p>
           </p:txBody>
@@ -27505,7 +27078,7 @@
           </p:nvCxnSpPr>
           <p:spPr>
             <a:xfrm>
-              <a:off x="606555" y="6419236"/>
+              <a:off x="-318200" y="6836355"/>
               <a:ext cx="579455" cy="0"/>
             </a:xfrm>
             <a:prstGeom prst="straightConnector1">
@@ -32917,7 +32490,7 @@
                     <a:prstClr val="black"/>
                   </a:solidFill>
                 </a:rPr>
-                <a:t>complete line 7</a:t>
+                <a:t>completes line 7</a:t>
               </a:r>
               <a:endParaRPr lang="en-US" sz="1600" dirty="0">
                 <a:solidFill>
@@ -34347,7 +33920,7 @@
                 <a:ea typeface="Calibri" panose="020F0502020204030204" pitchFamily="34" charset="0"/>
                 <a:cs typeface="Calibri" panose="020F0502020204030204" pitchFamily="34" charset="0"/>
               </a:rPr>
-              <a:t>This way of thinking and arguing, when we are presented with a solution to a synchronization problem/race-condition (i.e., try to “attack” it, try to find if it does not work), is practical and useful (and thus very common)</a:t>
+              <a:t>This way of thinking and arguing, when we are presented with a solution to a synchronization problem/race condition (i.e., try to “attack” it, try to determine whether it fails), is practical and useful (and thus very common)</a:t>
             </a:r>
           </a:p>
           <a:p>
@@ -34406,7 +33979,7 @@
                 <a:ea typeface="Calibri" panose="020F0502020204030204" pitchFamily="34" charset="0"/>
                 <a:cs typeface="Calibri" panose="020F0502020204030204" pitchFamily="34" charset="0"/>
               </a:rPr>
-              <a:t>_correct_, </a:t>
+              <a:t>correct, </a:t>
             </a:r>
             <a:r>
               <a:rPr lang="en-US" sz="1800" dirty="0">
@@ -34516,7 +34089,7 @@
                 <a:ea typeface="Calibri" panose="020F0502020204030204" pitchFamily="34" charset="0"/>
                 <a:cs typeface="Calibri" panose="020F0502020204030204" pitchFamily="34" charset="0"/>
               </a:rPr>
-              <a:t>counter-example, which implies that the proposition in focus is </a:t>
+              <a:t>counterexample, which implies that the proposition in focus is </a:t>
             </a:r>
             <a:r>
               <a:rPr lang="en-US" sz="1800" i="1" dirty="0">
@@ -34836,7 +34409,7 @@
                   </a:schemeClr>
                 </a:solidFill>
               </a:rPr>
-              <a:t>The Critical Section problem</a:t>
+              <a:t>The critical-section problem</a:t>
             </a:r>
           </a:p>
           <a:p>
@@ -35071,7 +34644,7 @@
           <a:p>
             <a:r>
               <a:rPr lang="en-US" dirty="0"/>
-              <a:t>The Critical Section problem</a:t>
+              <a:t>The critical-section problem</a:t>
             </a:r>
           </a:p>
           <a:p>
@@ -36292,7 +35865,7 @@
                 <a:ea typeface="MS PGothic" pitchFamily="34" charset="-128"/>
                 <a:cs typeface="Courier New" panose="02070309020205020404" pitchFamily="49" charset="0"/>
               </a:rPr>
-              <a:t>}</a:t>
+              <a:t>;}</a:t>
             </a:r>
             <a:r>
               <a:rPr kumimoji="1" lang="en-US" altLang="sv-SE" sz="1600" kern="0" dirty="0">
@@ -37157,7 +36730,7 @@
                 <a:ea typeface="+mn-ea"/>
                 <a:cs typeface="+mn-cs"/>
               </a:rPr>
-              <a:t>Homework training:</a:t>
+              <a:t>Homework:</a:t>
             </a:r>
             <a:r>
               <a:rPr kumimoji="0" lang="en-US" sz="1800" b="0" i="0" u="none" strike="noStrike" kern="1200" cap="none" spc="0" normalizeH="0" baseline="0" dirty="0">
@@ -37174,7 +36747,7 @@
                 <a:ea typeface="+mn-ea"/>
                 <a:cs typeface="+mn-cs"/>
               </a:rPr>
-              <a:t> argue as we did for Peterson’s algo regarding correctness (mutual exclusion, progress) ; what about fairness?</a:t>
+              <a:t> argue as we did for Peterson’s algo regarding correctness (mutual exclusion, progress); what about fairness?</a:t>
             </a:r>
           </a:p>
         </p:txBody>
@@ -37960,7 +37533,7 @@
                 <a:ea typeface="MS PGothic" pitchFamily="34" charset="-128"/>
                 <a:cs typeface="Courier New" panose="02070309020205020404" pitchFamily="49" charset="0"/>
               </a:rPr>
-              <a:t>}</a:t>
+              <a:t>;}</a:t>
             </a:r>
             <a:r>
               <a:rPr kumimoji="1" lang="en-US" altLang="sv-SE" sz="1600" kern="0" dirty="0">
@@ -38607,7 +38180,7 @@
                 <a:ea typeface="MS PGothic" pitchFamily="34" charset="-128"/>
                 <a:cs typeface="Courier New" panose="02070309020205020404" pitchFamily="49" charset="0"/>
               </a:rPr>
-              <a:t>  return temp} </a:t>
+              <a:t>  return temp;} </a:t>
             </a:r>
             <a:r>
               <a:rPr kumimoji="1" lang="en-US" altLang="sv-SE" sz="1600" b="0" i="0" u="none" strike="noStrike" kern="0" cap="none" spc="0" normalizeH="0" baseline="0" noProof="0" dirty="0">
@@ -39945,7 +39518,7 @@
                 <a:ea typeface="MS PGothic" pitchFamily="34" charset="-128"/>
                 <a:cs typeface="Courier New" panose="02070309020205020404" pitchFamily="49" charset="0"/>
               </a:rPr>
-              <a:t>lock := 0 ;</a:t>
+              <a:t>lock := 0;</a:t>
             </a:r>
             <a:r>
               <a:rPr kumimoji="1" lang="en-US" altLang="sv-SE" sz="1600" b="1" i="0" u="none" strike="noStrike" kern="0" cap="none" spc="0" normalizeH="0" baseline="0" noProof="0" dirty="0">
@@ -40046,7 +39619,7 @@
                 <a:ea typeface="MS PGothic" pitchFamily="34" charset="-128"/>
                 <a:cs typeface="Courier New" panose="02070309020205020404" pitchFamily="49" charset="0"/>
               </a:rPr>
-              <a:t>forever</a:t>
+              <a:t>}forever</a:t>
             </a:r>
           </a:p>
           <a:p>
@@ -40355,7 +39928,7 @@
                   <a:prstClr val="black"/>
                 </a:solidFill>
               </a:rPr>
-              <a:t>when  </a:t>
+              <a:t>when </a:t>
             </a:r>
             <a:r>
               <a:rPr lang="en-US" b="1" i="1" dirty="0">
@@ -40386,7 +39959,7 @@
                   <a:prstClr val="black"/>
                 </a:solidFill>
               </a:rPr>
-              <a:t>Even </a:t>
+              <a:t>Even a </a:t>
             </a:r>
             <a:r>
               <a:rPr lang="en-US" b="1" dirty="0">
@@ -40410,7 +39983,7 @@
                   <a:srgbClr val="C00000"/>
                 </a:solidFill>
               </a:rPr>
-              <a:t>non-preemptive priority-based scheduling</a:t>
+              <a:t>preemptive priority-based scheduling</a:t>
             </a:r>
             <a:r>
               <a:rPr lang="en-US" dirty="0">
@@ -40435,7 +40008,7 @@
                   <a:prstClr val="black"/>
                 </a:solidFill>
               </a:rPr>
-              <a:t>low priority thread LP executes in critical section </a:t>
+              <a:t>low-priority thread LP executes in critical section </a:t>
             </a:r>
           </a:p>
           <a:p>
@@ -40452,7 +40025,7 @@
                   <a:prstClr val="black"/>
                 </a:solidFill>
               </a:rPr>
-              <a:t>higher priority thread HP needs to access its CS</a:t>
+              <a:t>high-priority thread HP needs to access its CS</a:t>
             </a:r>
           </a:p>
           <a:p>
@@ -41351,25 +40924,8 @@
                   </a:schemeClr>
                 </a:solidFill>
               </a:rPr>
-              <a:t>//</a:t>
-            </a:r>
-            <a:r>
-              <a:rPr lang="en-US" sz="2000" dirty="0" err="1">
-                <a:solidFill>
-                  <a:schemeClr val="bg1">
-                    <a:lumMod val="50000"/>
-                  </a:schemeClr>
-                </a:solidFill>
-              </a:rPr>
-              <a:t>busywait</a:t>
-            </a:r>
-            <a:endParaRPr lang="en-US" sz="2000" dirty="0">
-              <a:solidFill>
-                <a:schemeClr val="bg1">
-                  <a:lumMod val="50000"/>
-                </a:schemeClr>
-              </a:solidFill>
-            </a:endParaRPr>
+              <a:t>//busy-wait</a:t>
+            </a:r>
           </a:p>
           <a:p>
             <a:pPr marL="457200" lvl="0" indent="-457200">
@@ -41456,7 +41012,7 @@
             </a:pPr>
             <a:r>
               <a:rPr lang="en-US" sz="2000" i="1" dirty="0"/>
-              <a:t>	j = (</a:t>
+              <a:t>	j := (</a:t>
             </a:r>
             <a:r>
               <a:rPr lang="en-US" sz="2000" i="1" dirty="0" err="1"/>
@@ -41550,7 +41106,7 @@
                   </a:schemeClr>
                 </a:solidFill>
               </a:rPr>
-              <a:t>(handover the “lock” )</a:t>
+              <a:t>(hand over the “lock” )</a:t>
             </a:r>
           </a:p>
           <a:p>
@@ -41745,20 +41301,12 @@
               <a:t>	</a:t>
             </a:r>
             <a:r>
-              <a:rPr lang="en-US" sz="2000" b="1" i="1">
+              <a:rPr lang="en-US" sz="2000" b="1" i="1" dirty="0">
                 <a:solidFill>
                   <a:srgbClr val="00B050"/>
                 </a:solidFill>
               </a:rPr>
-              <a:t>	waiting</a:t>
-            </a:r>
-            <a:r>
-              <a:rPr lang="en-US" sz="2000" b="1" i="1" dirty="0">
-                <a:solidFill>
-                  <a:srgbClr val="00B050"/>
-                </a:solidFill>
-              </a:rPr>
-              <a:t>[j] := false</a:t>
+              <a:t>	waiting[j] := false</a:t>
             </a:r>
             <a:r>
               <a:rPr lang="en-US" sz="2000" b="1" dirty="0">
@@ -41776,7 +41324,7 @@
                   </a:schemeClr>
                 </a:solidFill>
               </a:rPr>
-              <a:t>// hand-over “lock”</a:t>
+              <a:t>// hand over “lock”</a:t>
             </a:r>
           </a:p>
           <a:p>
@@ -42129,27 +41677,7 @@
                   </a:schemeClr>
                 </a:solidFill>
               </a:rPr>
-              <a:t>Critical section + bounded waiting with  </a:t>
-            </a:r>
-            <a:r>
-              <a:rPr lang="en-US" sz="3600" b="1" dirty="0" err="1">
-                <a:solidFill>
-                  <a:schemeClr val="accent1">
-                    <a:lumMod val="50000"/>
-                  </a:schemeClr>
-                </a:solidFill>
-              </a:rPr>
-              <a:t>TaS</a:t>
-            </a:r>
-            <a:r>
-              <a:rPr lang="en-US" sz="3600" b="1" dirty="0">
-                <a:solidFill>
-                  <a:schemeClr val="accent1">
-                    <a:lumMod val="50000"/>
-                  </a:schemeClr>
-                </a:solidFill>
-              </a:rPr>
-              <a:t> + busy-waiting for n threads</a:t>
+              <a:t>Critical section + bounded waiting with  TAS + busy-waiting for n threads</a:t>
             </a:r>
             <a:endParaRPr lang="sv-SE" sz="3600" b="1" dirty="0">
               <a:solidFill>
@@ -42288,7 +41816,7 @@
                   </a:schemeClr>
                 </a:solidFill>
               </a:rPr>
-              <a:t>The Critical Section problem</a:t>
+              <a:t>The critical-section problem</a:t>
             </a:r>
           </a:p>
           <a:p>
@@ -43292,7 +42820,7 @@
         </p:nvSpPr>
         <p:spPr>
           <a:xfrm>
-            <a:off x="6380401" y="4431799"/>
+            <a:off x="6603921" y="4477522"/>
             <a:ext cx="4973399" cy="670953"/>
           </a:xfrm>
           <a:prstGeom prst="rect">
@@ -44326,7 +43854,11 @@
             </a:pPr>
             <a:r>
               <a:rPr lang="en-US" sz="2000" dirty="0"/>
-              <a:t>Thread I</a:t>
+              <a:t>Thread </a:t>
+            </a:r>
+            <a:r>
+              <a:rPr lang="en-US" sz="2000" dirty="0" err="1"/>
+              <a:t>i</a:t>
             </a:r>
             <a:endParaRPr lang="en-US" sz="2000" baseline="-25000" dirty="0"/>
           </a:p>
@@ -45293,7 +44825,7 @@
                   </a:schemeClr>
                 </a:solidFill>
               </a:rPr>
-              <a:t>The Critical Section problem</a:t>
+              <a:t>The critical-section problem</a:t>
             </a:r>
           </a:p>
           <a:p>
@@ -45540,7 +45072,7 @@
                   </a:schemeClr>
                 </a:solidFill>
               </a:rPr>
-              <a:t>The Critical Section problem</a:t>
+              <a:t>The critical-section problem</a:t>
             </a:r>
           </a:p>
           <a:p>
@@ -45910,7 +45442,7 @@
                 <a:ea typeface="ＭＳ Ｐゴシック" charset="0"/>
                 <a:cs typeface="ＭＳ Ｐゴシック" charset="0"/>
               </a:rPr>
-              <a:t>Tools for programmers to solve critical section and synchronization problems (can be implemented using hardware atomic instructions or algorithms such as Peterson’s or other such tools</a:t>
+              <a:t>Tools for programmers to solve critical section and synchronization problems (can be implemented using hardware atomic instructions or algorithms such as Peterson’s or other such tools)</a:t>
             </a:r>
           </a:p>
           <a:p>
@@ -46123,14 +45655,14 @@
                 <a:ea typeface="ＭＳ Ｐゴシック" charset="0"/>
                 <a:cs typeface="ＭＳ Ｐゴシック" charset="-128"/>
               </a:rPr>
-              <a:t>busy waiting, </a:t>
+              <a:t>busy-waiting, </a:t>
             </a:r>
             <a:r>
               <a:rPr kumimoji="1" lang="en-US" sz="1800" kern="0" dirty="0">
                 <a:ea typeface="ＭＳ Ｐゴシック" charset="0"/>
                 <a:cs typeface="ＭＳ Ｐゴシック" charset="-128"/>
               </a:rPr>
-              <a:t>called</a:t>
+              <a:t>it is a</a:t>
             </a:r>
             <a:r>
               <a:rPr kumimoji="1" lang="en-US" sz="1800" kern="0" dirty="0">
@@ -46183,7 +45715,7 @@
                   <a:srgbClr val="0070C0"/>
                 </a:solidFill>
               </a:rPr>
-              <a:t> ()  </a:t>
+              <a:t>()  </a:t>
             </a:r>
             <a:r>
               <a:rPr lang="en-US" sz="1800" dirty="0"/>
@@ -46205,7 +45737,7 @@
                   <a:srgbClr val="0070C0"/>
                 </a:solidFill>
               </a:rPr>
-              <a:t> () </a:t>
+              <a:t>() </a:t>
             </a:r>
             <a:r>
               <a:rPr lang="en-US" sz="1800" dirty="0"/>
@@ -46221,7 +45753,7 @@
             </a:r>
             <a:r>
               <a:rPr lang="en-US" sz="1800" dirty="0"/>
-              <a:t>unblocks one of processes</a:t>
+              <a:t>unblocks one of the processes</a:t>
             </a:r>
             <a:r>
               <a:rPr lang="en-US" sz="1800" dirty="0">
@@ -46257,7 +45789,7 @@
                   <a:srgbClr val="0070C0"/>
                 </a:solidFill>
               </a:rPr>
-              <a:t> () </a:t>
+              <a:t>() </a:t>
             </a:r>
             <a:r>
               <a:rPr lang="en-US" sz="1800" dirty="0"/>
@@ -46479,7 +46011,7 @@
             <a:pPr eaLnBrk="1" hangingPunct="1"/>
             <a:r>
               <a:rPr lang="en-US" sz="4000" dirty="0"/>
-              <a:t>Linux Synchronization provides system calls for:</a:t>
+              <a:t>Linux Synchronization provides support for:</a:t>
             </a:r>
           </a:p>
         </p:txBody>
@@ -46531,7 +46063,7 @@
           <a:p>
             <a:r>
               <a:rPr lang="en-US" dirty="0"/>
-              <a:t>spin locks for </a:t>
+              <a:t>spinlocks for </a:t>
             </a:r>
             <a:r>
               <a:rPr lang="en-US" dirty="0">
@@ -46599,7 +46131,7 @@
             </a:r>
             <a:r>
               <a:rPr lang="en-US" i="1" dirty="0"/>
-              <a:t>; if already locked, then process enters blocked queue</a:t>
+              <a:t>; if already locked, then the calling thread enters blocked queue</a:t>
             </a:r>
             <a:r>
               <a:rPr lang="en-US" sz="2800" i="1" dirty="0"/>
@@ -46760,517 +46292,6 @@
 </file>
 
 <file path=ppt/slides/slide42.xml><?xml version="1.0" encoding="utf-8"?>
-<p:sld xmlns:a="http://schemas.openxmlformats.org/drawingml/2006/main" xmlns:r="http://schemas.openxmlformats.org/officeDocument/2006/relationships" xmlns:p="http://schemas.openxmlformats.org/presentationml/2006/main">
-  <p:cSld>
-    <p:spTree>
-      <p:nvGrpSpPr>
-        <p:cNvPr id="1" name=""/>
-        <p:cNvGrpSpPr/>
-        <p:nvPr/>
-      </p:nvGrpSpPr>
-      <p:grpSpPr>
-        <a:xfrm>
-          <a:off x="0" y="0"/>
-          <a:ext cx="0" cy="0"/>
-          <a:chOff x="0" y="0"/>
-          <a:chExt cx="0" cy="0"/>
-        </a:xfrm>
-      </p:grpSpPr>
-      <p:sp>
-        <p:nvSpPr>
-          <p:cNvPr id="31746" name="Rectangle 2"/>
-          <p:cNvSpPr>
-            <a:spLocks noGrp="1" noChangeArrowheads="1"/>
-          </p:cNvSpPr>
-          <p:nvPr>
-            <p:ph type="title"/>
-          </p:nvPr>
-        </p:nvSpPr>
-        <p:spPr/>
-        <p:txBody>
-          <a:bodyPr/>
-          <a:lstStyle/>
-          <a:p>
-            <a:pPr eaLnBrk="1" hangingPunct="1"/>
-            <a:r>
-              <a:rPr lang="en-US" dirty="0"/>
-              <a:t>Windows XP Synchronization</a:t>
-            </a:r>
-          </a:p>
-        </p:txBody>
-      </p:sp>
-      <p:sp>
-        <p:nvSpPr>
-          <p:cNvPr id="31747" name="Rectangle 3"/>
-          <p:cNvSpPr>
-            <a:spLocks noGrp="1" noChangeArrowheads="1"/>
-          </p:cNvSpPr>
-          <p:nvPr>
-            <p:ph idx="1"/>
-          </p:nvPr>
-        </p:nvSpPr>
-        <p:spPr>
-          <a:xfrm>
-            <a:off x="527381" y="1377383"/>
-            <a:ext cx="11265877" cy="3140786"/>
-          </a:xfrm>
-          <a:noFill/>
-          <a:ln>
-            <a:noFill/>
-          </a:ln>
-          <a:effectLst/>
-        </p:spPr>
-        <p:style>
-          <a:lnRef idx="1">
-            <a:schemeClr val="dk1"/>
-          </a:lnRef>
-          <a:fillRef idx="2">
-            <a:schemeClr val="dk1"/>
-          </a:fillRef>
-          <a:effectRef idx="1">
-            <a:schemeClr val="dk1"/>
-          </a:effectRef>
-          <a:fontRef idx="minor">
-            <a:schemeClr val="dk1"/>
-          </a:fontRef>
-        </p:style>
-        <p:txBody>
-          <a:bodyPr/>
-          <a:lstStyle/>
-          <a:p>
-            <a:r>
-              <a:rPr lang="en-US" dirty="0"/>
-              <a:t>processor-specific </a:t>
-            </a:r>
-            <a:r>
-              <a:rPr lang="en-US" dirty="0">
-                <a:solidFill>
-                  <a:srgbClr val="C00000"/>
-                </a:solidFill>
-              </a:rPr>
-              <a:t>interrupt masks </a:t>
-            </a:r>
-            <a:r>
-              <a:rPr lang="en-US" dirty="0"/>
-              <a:t>to protect access to global resources on uniprocessors </a:t>
-            </a:r>
-          </a:p>
-          <a:p>
-            <a:r>
-              <a:rPr lang="en-US" dirty="0">
-                <a:solidFill>
-                  <a:srgbClr val="C00000"/>
-                </a:solidFill>
-              </a:rPr>
-              <a:t>busy-wait spinlocks</a:t>
-            </a:r>
-            <a:r>
-              <a:rPr lang="en-US" dirty="0">
-                <a:solidFill>
-                  <a:srgbClr val="3366FF"/>
-                </a:solidFill>
-              </a:rPr>
-              <a:t> </a:t>
-            </a:r>
-            <a:r>
-              <a:rPr lang="en-US" dirty="0"/>
-              <a:t>on multiprocessors</a:t>
-            </a:r>
-          </a:p>
-          <a:p>
-            <a:pPr lvl="1"/>
-            <a:r>
-              <a:rPr lang="en-US" dirty="0"/>
-              <a:t>why not on uniprocessors?  </a:t>
-            </a:r>
-          </a:p>
-          <a:p>
-            <a:pPr lvl="1"/>
-            <a:r>
-              <a:rPr lang="en-US" dirty="0"/>
-              <a:t>[hint: can cause deadlocks if used with strict priority scheduling]</a:t>
-            </a:r>
-          </a:p>
-          <a:p>
-            <a:r>
-              <a:rPr lang="en-US" dirty="0">
-                <a:solidFill>
-                  <a:srgbClr val="C00000"/>
-                </a:solidFill>
-              </a:rPr>
-              <a:t>dispatcher objects </a:t>
-            </a:r>
-            <a:endParaRPr lang="en-US" dirty="0"/>
-          </a:p>
-          <a:p>
-            <a:pPr lvl="1"/>
-            <a:r>
-              <a:rPr lang="en-US" dirty="0"/>
-              <a:t>may act as </a:t>
-            </a:r>
-            <a:r>
-              <a:rPr lang="en-US" dirty="0" err="1">
-                <a:solidFill>
-                  <a:srgbClr val="C00000"/>
-                </a:solidFill>
-              </a:rPr>
-              <a:t>mutexes</a:t>
-            </a:r>
-            <a:r>
-              <a:rPr lang="en-US" dirty="0">
-                <a:solidFill>
-                  <a:srgbClr val="C00000"/>
-                </a:solidFill>
-              </a:rPr>
-              <a:t>, semaphores</a:t>
-            </a:r>
-            <a:r>
-              <a:rPr lang="en-US" dirty="0"/>
-              <a:t>, or provide </a:t>
-            </a:r>
-            <a:r>
-              <a:rPr lang="en-US" dirty="0">
-                <a:solidFill>
-                  <a:srgbClr val="C00000"/>
-                </a:solidFill>
-              </a:rPr>
-              <a:t>events </a:t>
-            </a:r>
-            <a:r>
-              <a:rPr lang="en-US" dirty="0"/>
-              <a:t>(similar to condition variables)</a:t>
-            </a:r>
-          </a:p>
-        </p:txBody>
-      </p:sp>
-      <p:sp>
-        <p:nvSpPr>
-          <p:cNvPr id="2" name="Slide Number Placeholder 1"/>
-          <p:cNvSpPr>
-            <a:spLocks noGrp="1"/>
-          </p:cNvSpPr>
-          <p:nvPr>
-            <p:ph type="sldNum" sz="quarter" idx="12"/>
-          </p:nvPr>
-        </p:nvSpPr>
-        <p:spPr/>
-        <p:txBody>
-          <a:bodyPr/>
-          <a:lstStyle/>
-          <a:p>
-            <a:pPr marL="0" marR="0" lvl="0" indent="0" algn="r" defTabSz="914400" rtl="0" eaLnBrk="1" fontAlgn="auto" latinLnBrk="0" hangingPunct="1">
-              <a:lnSpc>
-                <a:spcPct val="100000"/>
-              </a:lnSpc>
-              <a:spcBef>
-                <a:spcPts val="0"/>
-              </a:spcBef>
-              <a:spcAft>
-                <a:spcPts val="0"/>
-              </a:spcAft>
-              <a:buClrTx/>
-              <a:buSzTx/>
-              <a:buFontTx/>
-              <a:buNone/>
-              <a:tabLst/>
-              <a:defRPr/>
-            </a:pPr>
-            <a:fld id="{3F19581E-C58F-4F83-8FA8-2E7A8A7C33AE}" type="slidenum">
-              <a:rPr kumimoji="0" lang="en-US" sz="1200" b="0" i="0" u="none" strike="noStrike" kern="1200" cap="none" spc="0" normalizeH="0" baseline="0" noProof="0" smtClean="0">
-                <a:ln>
-                  <a:noFill/>
-                </a:ln>
-                <a:solidFill>
-                  <a:prstClr val="black">
-                    <a:tint val="75000"/>
-                  </a:prstClr>
-                </a:solidFill>
-                <a:effectLst/>
-                <a:uLnTx/>
-                <a:uFillTx/>
-                <a:latin typeface="Calibri"/>
-                <a:ea typeface="+mn-ea"/>
-                <a:cs typeface="+mn-cs"/>
-              </a:rPr>
-              <a:pPr marL="0" marR="0" lvl="0" indent="0" algn="r" defTabSz="914400" rtl="0" eaLnBrk="1" fontAlgn="auto" latinLnBrk="0" hangingPunct="1">
-                <a:lnSpc>
-                  <a:spcPct val="100000"/>
-                </a:lnSpc>
-                <a:spcBef>
-                  <a:spcPts val="0"/>
-                </a:spcBef>
-                <a:spcAft>
-                  <a:spcPts val="0"/>
-                </a:spcAft>
-                <a:buClrTx/>
-                <a:buSzTx/>
-                <a:buFontTx/>
-                <a:buNone/>
-                <a:tabLst/>
-                <a:defRPr/>
-              </a:pPr>
-              <a:t>42</a:t>
-            </a:fld>
-            <a:endParaRPr kumimoji="0" lang="en-US" sz="1200" b="0" i="0" u="none" strike="noStrike" kern="1200" cap="none" spc="0" normalizeH="0" baseline="0" noProof="0">
-              <a:ln>
-                <a:noFill/>
-              </a:ln>
-              <a:solidFill>
-                <a:prstClr val="black">
-                  <a:tint val="75000"/>
-                </a:prstClr>
-              </a:solidFill>
-              <a:effectLst/>
-              <a:uLnTx/>
-              <a:uFillTx/>
-              <a:latin typeface="Calibri"/>
-              <a:ea typeface="+mn-ea"/>
-              <a:cs typeface="+mn-cs"/>
-            </a:endParaRPr>
-          </a:p>
-        </p:txBody>
-      </p:sp>
-      <p:sp>
-        <p:nvSpPr>
-          <p:cNvPr id="5" name="Title 1"/>
-          <p:cNvSpPr txBox="1">
-            <a:spLocks/>
-          </p:cNvSpPr>
-          <p:nvPr/>
-        </p:nvSpPr>
-        <p:spPr bwMode="auto">
-          <a:xfrm>
-            <a:off x="527381" y="374426"/>
-            <a:ext cx="10959008" cy="576064"/>
-          </a:xfrm>
-          <a:prstGeom prst="rect">
-            <a:avLst/>
-          </a:prstGeom>
-          <a:noFill/>
-          <a:ln w="9525">
-            <a:noFill/>
-            <a:miter lim="800000"/>
-            <a:headEnd/>
-            <a:tailEnd/>
-          </a:ln>
-        </p:spPr>
-        <p:txBody>
-          <a:bodyPr vert="horz" wrap="square" lIns="91440" tIns="45720" rIns="91440" bIns="45720" numCol="1" anchor="ctr" anchorCtr="0" compatLnSpc="1">
-            <a:prstTxWarp prst="textNoShape">
-              <a:avLst/>
-            </a:prstTxWarp>
-          </a:bodyPr>
-          <a:lstStyle>
-            <a:lvl1pPr algn="l" rtl="0" eaLnBrk="0" fontAlgn="base" hangingPunct="0">
-              <a:spcBef>
-                <a:spcPct val="0"/>
-              </a:spcBef>
-              <a:spcAft>
-                <a:spcPct val="0"/>
-              </a:spcAft>
-              <a:defRPr sz="3600" b="1" kern="1200">
-                <a:solidFill>
-                  <a:schemeClr val="accent1">
-                    <a:lumMod val="50000"/>
-                  </a:schemeClr>
-                </a:solidFill>
-                <a:latin typeface="+mj-lt"/>
-                <a:ea typeface="+mj-ea"/>
-                <a:cs typeface="+mj-cs"/>
-              </a:defRPr>
-            </a:lvl1pPr>
-            <a:lvl2pPr algn="ctr" rtl="0" eaLnBrk="0" fontAlgn="base" hangingPunct="0">
-              <a:spcBef>
-                <a:spcPct val="0"/>
-              </a:spcBef>
-              <a:spcAft>
-                <a:spcPct val="0"/>
-              </a:spcAft>
-              <a:defRPr sz="4400">
-                <a:solidFill>
-                  <a:schemeClr val="tx1"/>
-                </a:solidFill>
-                <a:latin typeface="Calibri" pitchFamily="34" charset="0"/>
-              </a:defRPr>
-            </a:lvl2pPr>
-            <a:lvl3pPr algn="ctr" rtl="0" eaLnBrk="0" fontAlgn="base" hangingPunct="0">
-              <a:spcBef>
-                <a:spcPct val="0"/>
-              </a:spcBef>
-              <a:spcAft>
-                <a:spcPct val="0"/>
-              </a:spcAft>
-              <a:defRPr sz="4400">
-                <a:solidFill>
-                  <a:schemeClr val="tx1"/>
-                </a:solidFill>
-                <a:latin typeface="Calibri" pitchFamily="34" charset="0"/>
-              </a:defRPr>
-            </a:lvl3pPr>
-            <a:lvl4pPr algn="ctr" rtl="0" eaLnBrk="0" fontAlgn="base" hangingPunct="0">
-              <a:spcBef>
-                <a:spcPct val="0"/>
-              </a:spcBef>
-              <a:spcAft>
-                <a:spcPct val="0"/>
-              </a:spcAft>
-              <a:defRPr sz="4400">
-                <a:solidFill>
-                  <a:schemeClr val="tx1"/>
-                </a:solidFill>
-                <a:latin typeface="Calibri" pitchFamily="34" charset="0"/>
-              </a:defRPr>
-            </a:lvl4pPr>
-            <a:lvl5pPr algn="ctr" rtl="0" eaLnBrk="0" fontAlgn="base" hangingPunct="0">
-              <a:spcBef>
-                <a:spcPct val="0"/>
-              </a:spcBef>
-              <a:spcAft>
-                <a:spcPct val="0"/>
-              </a:spcAft>
-              <a:defRPr sz="4400">
-                <a:solidFill>
-                  <a:schemeClr val="tx1"/>
-                </a:solidFill>
-                <a:latin typeface="Calibri" pitchFamily="34" charset="0"/>
-              </a:defRPr>
-            </a:lvl5pPr>
-            <a:lvl6pPr marL="457200" algn="ctr" rtl="0" fontAlgn="base">
-              <a:spcBef>
-                <a:spcPct val="0"/>
-              </a:spcBef>
-              <a:spcAft>
-                <a:spcPct val="0"/>
-              </a:spcAft>
-              <a:defRPr sz="4400">
-                <a:solidFill>
-                  <a:schemeClr val="tx1"/>
-                </a:solidFill>
-                <a:latin typeface="Calibri" pitchFamily="34" charset="0"/>
-              </a:defRPr>
-            </a:lvl6pPr>
-            <a:lvl7pPr marL="914400" algn="ctr" rtl="0" fontAlgn="base">
-              <a:spcBef>
-                <a:spcPct val="0"/>
-              </a:spcBef>
-              <a:spcAft>
-                <a:spcPct val="0"/>
-              </a:spcAft>
-              <a:defRPr sz="4400">
-                <a:solidFill>
-                  <a:schemeClr val="tx1"/>
-                </a:solidFill>
-                <a:latin typeface="Calibri" pitchFamily="34" charset="0"/>
-              </a:defRPr>
-            </a:lvl7pPr>
-            <a:lvl8pPr marL="1371600" algn="ctr" rtl="0" fontAlgn="base">
-              <a:spcBef>
-                <a:spcPct val="0"/>
-              </a:spcBef>
-              <a:spcAft>
-                <a:spcPct val="0"/>
-              </a:spcAft>
-              <a:defRPr sz="4400">
-                <a:solidFill>
-                  <a:schemeClr val="tx1"/>
-                </a:solidFill>
-                <a:latin typeface="Calibri" pitchFamily="34" charset="0"/>
-              </a:defRPr>
-            </a:lvl8pPr>
-            <a:lvl9pPr marL="1828800" algn="ctr" rtl="0" fontAlgn="base">
-              <a:spcBef>
-                <a:spcPct val="0"/>
-              </a:spcBef>
-              <a:spcAft>
-                <a:spcPct val="0"/>
-              </a:spcAft>
-              <a:defRPr sz="4400">
-                <a:solidFill>
-                  <a:schemeClr val="tx1"/>
-                </a:solidFill>
-                <a:latin typeface="Calibri" pitchFamily="34" charset="0"/>
-              </a:defRPr>
-            </a:lvl9pPr>
-          </a:lstStyle>
-          <a:p>
-            <a:pPr marL="0" marR="0" lvl="0" indent="0" algn="l" defTabSz="914400" rtl="0" eaLnBrk="0" fontAlgn="base" latinLnBrk="0" hangingPunct="0">
-              <a:lnSpc>
-                <a:spcPct val="100000"/>
-              </a:lnSpc>
-              <a:spcBef>
-                <a:spcPct val="0"/>
-              </a:spcBef>
-              <a:spcAft>
-                <a:spcPct val="0"/>
-              </a:spcAft>
-              <a:buClrTx/>
-              <a:buSzTx/>
-              <a:buFontTx/>
-              <a:buNone/>
-              <a:tabLst/>
-              <a:defRPr/>
-            </a:pPr>
-            <a:endParaRPr kumimoji="0" lang="sv-SE" sz="3200" b="1" i="0" u="none" strike="noStrike" kern="1200" cap="none" spc="0" normalizeH="0" baseline="0" noProof="0" dirty="0">
-              <a:ln>
-                <a:noFill/>
-              </a:ln>
-              <a:solidFill>
-                <a:srgbClr val="4F81BD">
-                  <a:lumMod val="50000"/>
-                </a:srgbClr>
-              </a:solidFill>
-              <a:effectLst/>
-              <a:uLnTx/>
-              <a:uFillTx/>
-              <a:latin typeface="Calibri"/>
-              <a:ea typeface="+mj-ea"/>
-              <a:cs typeface="+mj-cs"/>
-            </a:endParaRPr>
-          </a:p>
-        </p:txBody>
-      </p:sp>
-      <p:sp>
-        <p:nvSpPr>
-          <p:cNvPr id="3" name="Date Placeholder 2">
-            <a:extLst>
-              <a:ext uri="{FF2B5EF4-FFF2-40B4-BE49-F238E27FC236}">
-                <a16:creationId xmlns:a16="http://schemas.microsoft.com/office/drawing/2014/main" id="{5AB89A1B-3719-3D82-7C1D-9154CC396088}"/>
-              </a:ext>
-            </a:extLst>
-          </p:cNvPr>
-          <p:cNvSpPr>
-            <a:spLocks noGrp="1"/>
-          </p:cNvSpPr>
-          <p:nvPr>
-            <p:ph type="dt" sz="half" idx="10"/>
-          </p:nvPr>
-        </p:nvSpPr>
-        <p:spPr/>
-        <p:txBody>
-          <a:bodyPr/>
-          <a:lstStyle/>
-          <a:p>
-            <a:r>
-              <a:rPr lang="en-US"/>
-              <a:t>Vincenzo Gulisano</a:t>
-            </a:r>
-          </a:p>
-        </p:txBody>
-      </p:sp>
-    </p:spTree>
-    <p:extLst>
-      <p:ext uri="{BB962C8B-B14F-4D97-AF65-F5344CB8AC3E}">
-        <p14:creationId xmlns:p14="http://schemas.microsoft.com/office/powerpoint/2010/main" val="1704133692"/>
-      </p:ext>
-    </p:extLst>
-  </p:cSld>
-  <p:clrMapOvr>
-    <a:masterClrMapping/>
-  </p:clrMapOvr>
-</p:sld>
-</file>
-
-<file path=ppt/slides/slide43.xml><?xml version="1.0" encoding="utf-8"?>
 <p:sld xmlns:a="http://schemas.openxmlformats.org/drawingml/2006/main" xmlns:r="http://schemas.openxmlformats.org/officeDocument/2006/relationships" xmlns:p="http://schemas.openxmlformats.org/presentationml/2006/main">
   <p:cSld>
     <p:spTree>
@@ -47378,7 +46399,9 @@
           </a:fontRef>
         </p:style>
         <p:txBody>
-          <a:bodyPr/>
+          <a:bodyPr>
+            <a:normAutofit/>
+          </a:bodyPr>
           <a:lstStyle/>
           <a:p>
             <a:pPr marL="0" indent="0">
@@ -47390,7 +46413,7 @@
                   <a:srgbClr val="C00000"/>
                 </a:solidFill>
               </a:rPr>
-              <a:t>OS-independent; </a:t>
+              <a:t>A specification, not an implementation; </a:t>
             </a:r>
             <a:r>
               <a:rPr lang="en-US" dirty="0"/>
@@ -47408,12 +46431,9 @@
                   <a:srgbClr val="C00000"/>
                 </a:solidFill>
               </a:rPr>
-              <a:t>locks with blocking queues </a:t>
-            </a:r>
-            <a:r>
-              <a:rPr lang="en-US" dirty="0"/>
-              <a:t>(also fairness in mind)</a:t>
-            </a:r>
+              <a:t>locks with blocking queues</a:t>
+            </a:r>
+            <a:endParaRPr lang="en-US" dirty="0"/>
           </a:p>
           <a:p>
             <a:r>
@@ -47492,7 +46512,7 @@
 </p:sld>
 </file>
 
-<file path=ppt/slides/slide44.xml><?xml version="1.0" encoding="utf-8"?>
+<file path=ppt/slides/slide43.xml><?xml version="1.0" encoding="utf-8"?>
 <p:sld xmlns:a="http://schemas.openxmlformats.org/drawingml/2006/main" xmlns:r="http://schemas.openxmlformats.org/officeDocument/2006/relationships" xmlns:p="http://schemas.openxmlformats.org/presentationml/2006/main">
   <p:cSld>
     <p:bg>
@@ -47824,50 +46844,6 @@
       </p:sp>
       <p:sp>
         <p:nvSpPr>
-          <p:cNvPr id="4" name="Footer Placeholder 3">
-            <a:extLst>
-              <a:ext uri="{FF2B5EF4-FFF2-40B4-BE49-F238E27FC236}">
-                <a16:creationId xmlns:a16="http://schemas.microsoft.com/office/drawing/2014/main" id="{564DBAEA-6B43-ECC3-AD74-5067BCEEECDF}"/>
-              </a:ext>
-            </a:extLst>
-          </p:cNvPr>
-          <p:cNvSpPr>
-            <a:spLocks noGrp="1"/>
-          </p:cNvSpPr>
-          <p:nvPr>
-            <p:ph type="ftr" sz="quarter" idx="11"/>
-          </p:nvPr>
-        </p:nvSpPr>
-        <p:spPr/>
-        <p:txBody>
-          <a:bodyPr/>
-          <a:lstStyle/>
-          <a:p>
-            <a:pPr eaLnBrk="0" fontAlgn="base" hangingPunct="0">
-              <a:spcBef>
-                <a:spcPct val="0"/>
-              </a:spcBef>
-              <a:spcAft>
-                <a:spcPct val="0"/>
-              </a:spcAft>
-            </a:pPr>
-            <a:r>
-              <a:rPr lang="en-US">
-                <a:solidFill>
-                  <a:prstClr val="black">
-                    <a:tint val="75000"/>
-                  </a:prstClr>
-                </a:solidFill>
-                <a:latin typeface="Verdana" panose="020B0604030504040204" pitchFamily="34" charset="0"/>
-                <a:ea typeface="MS PGothic" panose="020B0600070205080204" pitchFamily="34" charset="-128"/>
-              </a:rPr>
-              <a:t>Operating Systems - Processes</a:t>
-            </a:r>
-          </a:p>
-        </p:txBody>
-      </p:sp>
-      <p:sp>
-        <p:nvSpPr>
           <p:cNvPr id="5" name="Slide Number Placeholder 4">
             <a:extLst>
               <a:ext uri="{FF2B5EF4-FFF2-40B4-BE49-F238E27FC236}">
@@ -47913,7 +46889,7 @@
                   <a:spcPct val="0"/>
                 </a:spcAft>
               </a:pPr>
-              <a:t>44</a:t>
+              <a:t>43</a:t>
             </a:fld>
             <a:endParaRPr lang="en-US">
               <a:solidFill>
@@ -47940,7 +46916,7 @@
 </p:sld>
 </file>
 
-<file path=ppt/slides/slide45.xml><?xml version="1.0" encoding="utf-8"?>
+<file path=ppt/slides/slide44.xml><?xml version="1.0" encoding="utf-8"?>
 <p:sld xmlns:a="http://schemas.openxmlformats.org/drawingml/2006/main" xmlns:r="http://schemas.openxmlformats.org/officeDocument/2006/relationships" xmlns:p="http://schemas.openxmlformats.org/presentationml/2006/main">
   <p:cSld>
     <p:spTree>
@@ -48119,7 +47095,7 @@
           <a:p>
             <a:fld id="{67FCC1A6-2294-BF46-A2F7-E6BDB92DF1BF}" type="slidenum">
               <a:rPr lang="en-US" smtClean="0"/>
-              <a:t>45</a:t>
+              <a:t>44</a:t>
             </a:fld>
             <a:endParaRPr lang="en-US"/>
           </a:p>
@@ -48395,444 +47371,7 @@
 </p:sld>
 </file>
 
-<file path=ppt/slides/slide46.xml><?xml version="1.0" encoding="utf-8"?>
-<p:sld xmlns:a="http://schemas.openxmlformats.org/drawingml/2006/main" xmlns:r="http://schemas.openxmlformats.org/officeDocument/2006/relationships" xmlns:p="http://schemas.openxmlformats.org/presentationml/2006/main">
-  <p:cSld>
-    <p:spTree>
-      <p:nvGrpSpPr>
-        <p:cNvPr id="1" name="">
-          <a:extLst>
-            <a:ext uri="{FF2B5EF4-FFF2-40B4-BE49-F238E27FC236}">
-              <a16:creationId xmlns:a16="http://schemas.microsoft.com/office/drawing/2014/main" id="{89D213B1-ABF0-2E0B-4042-3013B9DEBBCE}"/>
-            </a:ext>
-          </a:extLst>
-        </p:cNvPr>
-        <p:cNvGrpSpPr/>
-        <p:nvPr/>
-      </p:nvGrpSpPr>
-      <p:grpSpPr>
-        <a:xfrm>
-          <a:off x="0" y="0"/>
-          <a:ext cx="0" cy="0"/>
-          <a:chOff x="0" y="0"/>
-          <a:chExt cx="0" cy="0"/>
-        </a:xfrm>
-      </p:grpSpPr>
-      <p:sp>
-        <p:nvSpPr>
-          <p:cNvPr id="2" name="Title 1">
-            <a:extLst>
-              <a:ext uri="{FF2B5EF4-FFF2-40B4-BE49-F238E27FC236}">
-                <a16:creationId xmlns:a16="http://schemas.microsoft.com/office/drawing/2014/main" id="{FAF3AB8A-C7F9-AA12-E5B9-92816D1A8423}"/>
-              </a:ext>
-            </a:extLst>
-          </p:cNvPr>
-          <p:cNvSpPr>
-            <a:spLocks noGrp="1"/>
-          </p:cNvSpPr>
-          <p:nvPr>
-            <p:ph type="title"/>
-          </p:nvPr>
-        </p:nvSpPr>
-        <p:spPr/>
-        <p:txBody>
-          <a:bodyPr/>
-          <a:lstStyle/>
-          <a:p>
-            <a:r>
-              <a:rPr lang="en-US" dirty="0"/>
-              <a:t>Question</a:t>
-            </a:r>
-          </a:p>
-        </p:txBody>
-      </p:sp>
-      <p:sp>
-        <p:nvSpPr>
-          <p:cNvPr id="3" name="Content Placeholder 2">
-            <a:extLst>
-              <a:ext uri="{FF2B5EF4-FFF2-40B4-BE49-F238E27FC236}">
-                <a16:creationId xmlns:a16="http://schemas.microsoft.com/office/drawing/2014/main" id="{0A4E92D1-AAFA-451F-85FB-B8745F330658}"/>
-              </a:ext>
-            </a:extLst>
-          </p:cNvPr>
-          <p:cNvSpPr>
-            <a:spLocks noGrp="1"/>
-          </p:cNvSpPr>
-          <p:nvPr>
-            <p:ph idx="1"/>
-          </p:nvPr>
-        </p:nvSpPr>
-        <p:spPr/>
-        <p:txBody>
-          <a:bodyPr/>
-          <a:lstStyle/>
-          <a:p>
-            <a:r>
-              <a:rPr lang="en-US" dirty="0"/>
-              <a:t>Consider the following semaphore setup:</a:t>
-            </a:r>
-          </a:p>
-          <a:p>
-            <a:pPr lvl="1"/>
-            <a:r>
-              <a:rPr lang="en-US" dirty="0" err="1"/>
-              <a:t>semA</a:t>
-            </a:r>
-            <a:r>
-              <a:rPr lang="en-US" dirty="0"/>
-              <a:t> = 1;</a:t>
-            </a:r>
-          </a:p>
-          <a:p>
-            <a:pPr lvl="1"/>
-            <a:r>
-              <a:rPr lang="en-US" dirty="0" err="1"/>
-              <a:t>semB</a:t>
-            </a:r>
-            <a:r>
-              <a:rPr lang="en-US" dirty="0"/>
-              <a:t> = 0;</a:t>
-            </a:r>
-          </a:p>
-          <a:p>
-            <a:pPr lvl="1"/>
-            <a:r>
-              <a:rPr lang="en-US" dirty="0" err="1"/>
-              <a:t>semC</a:t>
-            </a:r>
-            <a:r>
-              <a:rPr lang="en-US" dirty="0"/>
-              <a:t> = 0;</a:t>
-            </a:r>
-          </a:p>
-          <a:p>
-            <a:pPr lvl="1"/>
-            <a:endParaRPr lang="en-US" dirty="0"/>
-          </a:p>
-          <a:p>
-            <a:pPr lvl="1"/>
-            <a:endParaRPr lang="en-US" dirty="0"/>
-          </a:p>
-          <a:p>
-            <a:pPr lvl="1"/>
-            <a:endParaRPr lang="en-US" dirty="0"/>
-          </a:p>
-          <a:p>
-            <a:pPr lvl="1"/>
-            <a:endParaRPr lang="en-US" dirty="0"/>
-          </a:p>
-          <a:p>
-            <a:r>
-              <a:rPr lang="en-US" dirty="0"/>
-              <a:t>Is sequence is valid?</a:t>
-            </a:r>
-          </a:p>
-          <a:p>
-            <a:pPr lvl="1"/>
-            <a:endParaRPr lang="en-US" dirty="0"/>
-          </a:p>
-        </p:txBody>
-      </p:sp>
-      <p:sp>
-        <p:nvSpPr>
-          <p:cNvPr id="4" name="Slide Number Placeholder 3">
-            <a:extLst>
-              <a:ext uri="{FF2B5EF4-FFF2-40B4-BE49-F238E27FC236}">
-                <a16:creationId xmlns:a16="http://schemas.microsoft.com/office/drawing/2014/main" id="{579ABCBF-3605-9640-3FA9-AF9FB54CB82C}"/>
-              </a:ext>
-            </a:extLst>
-          </p:cNvPr>
-          <p:cNvSpPr>
-            <a:spLocks noGrp="1"/>
-          </p:cNvSpPr>
-          <p:nvPr>
-            <p:ph type="sldNum" sz="quarter" idx="12"/>
-          </p:nvPr>
-        </p:nvSpPr>
-        <p:spPr/>
-        <p:txBody>
-          <a:bodyPr/>
-          <a:lstStyle/>
-          <a:p>
-            <a:fld id="{67FCC1A6-2294-BF46-A2F7-E6BDB92DF1BF}" type="slidenum">
-              <a:rPr lang="en-US" smtClean="0"/>
-              <a:t>46</a:t>
-            </a:fld>
-            <a:endParaRPr lang="en-US"/>
-          </a:p>
-        </p:txBody>
-      </p:sp>
-      <p:sp>
-        <p:nvSpPr>
-          <p:cNvPr id="6" name="TextBox 5">
-            <a:extLst>
-              <a:ext uri="{FF2B5EF4-FFF2-40B4-BE49-F238E27FC236}">
-                <a16:creationId xmlns:a16="http://schemas.microsoft.com/office/drawing/2014/main" id="{53BD2C1C-1390-E365-307C-12071A8A807E}"/>
-              </a:ext>
-            </a:extLst>
-          </p:cNvPr>
-          <p:cNvSpPr txBox="1"/>
-          <p:nvPr/>
-        </p:nvSpPr>
-        <p:spPr>
-          <a:xfrm>
-            <a:off x="4366647" y="3064199"/>
-            <a:ext cx="1584702" cy="1477328"/>
-          </a:xfrm>
-          <a:prstGeom prst="rect">
-            <a:avLst/>
-          </a:prstGeom>
-          <a:noFill/>
-        </p:spPr>
-        <p:txBody>
-          <a:bodyPr wrap="square">
-            <a:spAutoFit/>
-          </a:bodyPr>
-          <a:lstStyle/>
-          <a:p>
-            <a:r>
-              <a:rPr lang="en-US" dirty="0"/>
-              <a:t>THREAD X</a:t>
-            </a:r>
-            <a:br>
-              <a:rPr lang="en-US" dirty="0"/>
-            </a:br>
-            <a:endParaRPr lang="en-US" dirty="0"/>
-          </a:p>
-          <a:p>
-            <a:r>
-              <a:rPr lang="en-US" dirty="0"/>
-              <a:t>wait(</a:t>
-            </a:r>
-            <a:r>
-              <a:rPr lang="en-US" dirty="0" err="1"/>
-              <a:t>semA</a:t>
-            </a:r>
-            <a:r>
-              <a:rPr lang="en-US" dirty="0"/>
-              <a:t>);</a:t>
-            </a:r>
-          </a:p>
-          <a:p>
-            <a:r>
-              <a:rPr lang="en-US" dirty="0" err="1"/>
-              <a:t>opX</a:t>
-            </a:r>
-            <a:r>
-              <a:rPr lang="en-US" dirty="0"/>
-              <a:t>;</a:t>
-            </a:r>
-          </a:p>
-          <a:p>
-            <a:r>
-              <a:rPr lang="en-US" dirty="0"/>
-              <a:t>signal(</a:t>
-            </a:r>
-            <a:r>
-              <a:rPr lang="en-US" dirty="0" err="1"/>
-              <a:t>semB</a:t>
-            </a:r>
-            <a:r>
-              <a:rPr lang="en-US" dirty="0"/>
-              <a:t>);</a:t>
-            </a:r>
-          </a:p>
-        </p:txBody>
-      </p:sp>
-      <p:sp>
-        <p:nvSpPr>
-          <p:cNvPr id="8" name="TextBox 7">
-            <a:extLst>
-              <a:ext uri="{FF2B5EF4-FFF2-40B4-BE49-F238E27FC236}">
-                <a16:creationId xmlns:a16="http://schemas.microsoft.com/office/drawing/2014/main" id="{EE94DE3D-F51D-5B04-E56E-3605BCE8D1CC}"/>
-              </a:ext>
-            </a:extLst>
-          </p:cNvPr>
-          <p:cNvSpPr txBox="1"/>
-          <p:nvPr/>
-        </p:nvSpPr>
-        <p:spPr>
-          <a:xfrm>
-            <a:off x="6096000" y="3064199"/>
-            <a:ext cx="3046708" cy="1477328"/>
-          </a:xfrm>
-          <a:prstGeom prst="rect">
-            <a:avLst/>
-          </a:prstGeom>
-          <a:noFill/>
-        </p:spPr>
-        <p:txBody>
-          <a:bodyPr wrap="square">
-            <a:spAutoFit/>
-          </a:bodyPr>
-          <a:lstStyle/>
-          <a:p>
-            <a:r>
-              <a:rPr lang="en-US" dirty="0"/>
-              <a:t>THREAD Y</a:t>
-            </a:r>
-          </a:p>
-          <a:p>
-            <a:endParaRPr lang="en-US" dirty="0"/>
-          </a:p>
-          <a:p>
-            <a:r>
-              <a:rPr lang="en-US" dirty="0"/>
-              <a:t>wait(</a:t>
-            </a:r>
-            <a:r>
-              <a:rPr lang="en-US" dirty="0" err="1"/>
-              <a:t>semB</a:t>
-            </a:r>
-            <a:r>
-              <a:rPr lang="en-US" dirty="0"/>
-              <a:t>);</a:t>
-            </a:r>
-          </a:p>
-          <a:p>
-            <a:r>
-              <a:rPr lang="en-US" dirty="0" err="1"/>
-              <a:t>opY</a:t>
-            </a:r>
-            <a:r>
-              <a:rPr lang="en-US" dirty="0"/>
-              <a:t>;</a:t>
-            </a:r>
-          </a:p>
-          <a:p>
-            <a:r>
-              <a:rPr lang="en-US" dirty="0"/>
-              <a:t>signal(</a:t>
-            </a:r>
-            <a:r>
-              <a:rPr lang="en-US" dirty="0" err="1"/>
-              <a:t>semC</a:t>
-            </a:r>
-            <a:r>
-              <a:rPr lang="en-US" dirty="0"/>
-              <a:t>);</a:t>
-            </a:r>
-          </a:p>
-        </p:txBody>
-      </p:sp>
-      <p:sp>
-        <p:nvSpPr>
-          <p:cNvPr id="10" name="TextBox 9">
-            <a:extLst>
-              <a:ext uri="{FF2B5EF4-FFF2-40B4-BE49-F238E27FC236}">
-                <a16:creationId xmlns:a16="http://schemas.microsoft.com/office/drawing/2014/main" id="{E424BF86-471D-8962-783B-795BA85D345F}"/>
-              </a:ext>
-            </a:extLst>
-          </p:cNvPr>
-          <p:cNvSpPr txBox="1"/>
-          <p:nvPr/>
-        </p:nvSpPr>
-        <p:spPr>
-          <a:xfrm>
-            <a:off x="8045557" y="3064199"/>
-            <a:ext cx="2483603" cy="1477328"/>
-          </a:xfrm>
-          <a:prstGeom prst="rect">
-            <a:avLst/>
-          </a:prstGeom>
-          <a:noFill/>
-        </p:spPr>
-        <p:txBody>
-          <a:bodyPr wrap="square">
-            <a:spAutoFit/>
-          </a:bodyPr>
-          <a:lstStyle/>
-          <a:p>
-            <a:r>
-              <a:rPr lang="en-US" dirty="0"/>
-              <a:t>THREAD Z</a:t>
-            </a:r>
-          </a:p>
-          <a:p>
-            <a:endParaRPr lang="en-US" dirty="0"/>
-          </a:p>
-          <a:p>
-            <a:r>
-              <a:rPr lang="en-US" dirty="0"/>
-              <a:t>wait(</a:t>
-            </a:r>
-            <a:r>
-              <a:rPr lang="en-US" dirty="0" err="1"/>
-              <a:t>semC</a:t>
-            </a:r>
-            <a:r>
-              <a:rPr lang="en-US" dirty="0"/>
-              <a:t>);</a:t>
-            </a:r>
-          </a:p>
-          <a:p>
-            <a:r>
-              <a:rPr lang="en-US" dirty="0" err="1"/>
-              <a:t>opZ</a:t>
-            </a:r>
-            <a:r>
-              <a:rPr lang="en-US" dirty="0"/>
-              <a:t>;</a:t>
-            </a:r>
-          </a:p>
-          <a:p>
-            <a:r>
-              <a:rPr lang="en-US" dirty="0"/>
-              <a:t>signal(</a:t>
-            </a:r>
-            <a:r>
-              <a:rPr lang="en-US" dirty="0" err="1"/>
-              <a:t>semA</a:t>
-            </a:r>
-            <a:r>
-              <a:rPr lang="en-US" dirty="0"/>
-              <a:t>);</a:t>
-            </a:r>
-          </a:p>
-        </p:txBody>
-      </p:sp>
-      <p:sp>
-        <p:nvSpPr>
-          <p:cNvPr id="5" name="Date Placeholder 4">
-            <a:extLst>
-              <a:ext uri="{FF2B5EF4-FFF2-40B4-BE49-F238E27FC236}">
-                <a16:creationId xmlns:a16="http://schemas.microsoft.com/office/drawing/2014/main" id="{6BC5B370-1790-62C9-8849-5F400FB524DF}"/>
-              </a:ext>
-            </a:extLst>
-          </p:cNvPr>
-          <p:cNvSpPr>
-            <a:spLocks noGrp="1"/>
-          </p:cNvSpPr>
-          <p:nvPr>
-            <p:ph type="dt" sz="half" idx="10"/>
-          </p:nvPr>
-        </p:nvSpPr>
-        <p:spPr/>
-        <p:txBody>
-          <a:bodyPr/>
-          <a:lstStyle/>
-          <a:p>
-            <a:r>
-              <a:rPr lang="en-US"/>
-              <a:t>Vincenzo Gulisano</a:t>
-            </a:r>
-          </a:p>
-        </p:txBody>
-      </p:sp>
-    </p:spTree>
-    <p:extLst>
-      <p:ext uri="{BB962C8B-B14F-4D97-AF65-F5344CB8AC3E}">
-        <p14:creationId xmlns:p14="http://schemas.microsoft.com/office/powerpoint/2010/main" val="2325556078"/>
-      </p:ext>
-    </p:extLst>
-  </p:cSld>
-  <p:clrMapOvr>
-    <a:masterClrMapping/>
-  </p:clrMapOvr>
-</p:sld>
-</file>
-
-<file path=ppt/slides/slide47.xml><?xml version="1.0" encoding="utf-8"?>
+<file path=ppt/slides/slide45.xml><?xml version="1.0" encoding="utf-8"?>
 <p:sld xmlns:a="http://schemas.openxmlformats.org/drawingml/2006/main" xmlns:r="http://schemas.openxmlformats.org/officeDocument/2006/relationships" xmlns:p="http://schemas.openxmlformats.org/presentationml/2006/main">
   <p:cSld>
     <p:spTree>
@@ -49041,7 +47580,7 @@
           <a:p>
             <a:fld id="{67FCC1A6-2294-BF46-A2F7-E6BDB92DF1BF}" type="slidenum">
               <a:rPr lang="en-US" smtClean="0"/>
-              <a:t>47</a:t>
+              <a:t>45</a:t>
             </a:fld>
             <a:endParaRPr lang="en-US"/>
           </a:p>
@@ -49317,7 +47856,7 @@
 </p:sld>
 </file>
 
-<file path=ppt/slides/slide48.xml><?xml version="1.0" encoding="utf-8"?>
+<file path=ppt/slides/slide46.xml><?xml version="1.0" encoding="utf-8"?>
 <p:sld xmlns:a="http://schemas.openxmlformats.org/drawingml/2006/main" xmlns:r="http://schemas.openxmlformats.org/officeDocument/2006/relationships" xmlns:p="http://schemas.openxmlformats.org/presentationml/2006/main">
   <p:cSld>
     <p:spTree>
@@ -49360,7 +47899,7 @@
             </a:pPr>
             <a:r>
               <a:rPr lang="en-US" dirty="0"/>
-              <a:t>If two threads share memory, one thread with high priority wants to enter the critical section but another thread with lower priority was in the CS before, and the scheduling is non-preemptive priority based, that could lead to:</a:t>
+              <a:t>If two threads share memory, one thread with high priority wants to enter the critical section, it busy-waits for the same lock, but another thread with lower priority is in the CS, and the scheduling is preemptive priority based, that could lead to:</a:t>
             </a:r>
           </a:p>
           <a:p>
@@ -49449,7 +47988,7 @@
           <a:p>
             <a:fld id="{67FCC1A6-2294-BF46-A2F7-E6BDB92DF1BF}" type="slidenum">
               <a:rPr lang="en-US" smtClean="0"/>
-              <a:t>48</a:t>
+              <a:t>46</a:t>
             </a:fld>
             <a:endParaRPr lang="en-US"/>
           </a:p>
@@ -49468,7 +48007,7 @@
 </p:sld>
 </file>
 
-<file path=ppt/slides/slide49.xml><?xml version="1.0" encoding="utf-8"?>
+<file path=ppt/slides/slide47.xml><?xml version="1.0" encoding="utf-8"?>
 <p:sld xmlns:a="http://schemas.openxmlformats.org/drawingml/2006/main" xmlns:r="http://schemas.openxmlformats.org/officeDocument/2006/relationships" xmlns:p="http://schemas.openxmlformats.org/presentationml/2006/main">
   <p:cSld>
     <p:spTree>
@@ -49564,7 +48103,7 @@
           <a:p>
             <a:fld id="{67FCC1A6-2294-BF46-A2F7-E6BDB92DF1BF}" type="slidenum">
               <a:rPr lang="en-US" smtClean="0"/>
-              <a:t>49</a:t>
+              <a:t>47</a:t>
             </a:fld>
             <a:endParaRPr lang="en-US"/>
           </a:p>
@@ -51410,7 +49949,7 @@
             <a:pPr lvl="1"/>
             <a:r>
               <a:rPr lang="en-US" dirty="0"/>
-              <a:t>A and B run 3 instructions to update S (see figure)</a:t>
+              <a:t>A and B run 3 operations to update S (see figure)</a:t>
             </a:r>
           </a:p>
           <a:p>
@@ -52377,7 +50916,7 @@
           <a:p>
             <a:r>
               <a:rPr lang="en-US" dirty="0"/>
-              <a:t>Here we say S takes values 20, 70 and then 0</a:t>
+              <a:t>In this execution, S takes values 20, 70 and then 0</a:t>
             </a:r>
           </a:p>
           <a:p>
@@ -53570,7 +52109,7 @@
           <a:p>
             <a:r>
               <a:rPr lang="en-US" dirty="0"/>
-              <a:t>The Critical Section problem</a:t>
+              <a:t>The critical-section problem</a:t>
             </a:r>
           </a:p>
           <a:p>

</xml_diff>